<commit_message>
System Design vi: sd-14-025 deck says the listener still sees the client address
Co-Authored-By: Claude Sonnet 5.5 <noreply@anthropic.com>
Claude-Session: https://claude.ai/code/session_01WnjciXNJBLEd8jy3HrG49S
</commit_message>
<xml_diff>
--- a/system-design-101/vi/lessons/sd-14-025/slides/sd-14-025.pptx
+++ b/system-design-101/vi/lessons/sd-14-025/slides/sd-14-025.pptx
@@ -2109,7 +2109,7 @@
       </p:sp>
       <p:sp>
         <p:nvSpPr>
-          <p:cNvPr id="5" name="Connector line-1792370920832-524640939"/>
+          <p:cNvPr id="5" name="Connector line-1792405368109-354836357"/>
           <p:cNvSpPr/>
           <p:nvPr/>
         </p:nvSpPr>
@@ -2475,7 +2475,7 @@
               <a:buNone/>
             </a:pPr>
             <a:r>
-              <a:rPr lang="en-US" sz="1800" dirty="0" spc="0" kern="0">
+              <a:rPr lang="en-US" sz="1800" dirty="0" spc="-8" kern="0">
                 <a:solidFill>
                   <a:srgbClr val="9A98A0"/>
                 </a:solidFill>
@@ -2483,10 +2483,10 @@
                 <a:ea typeface="Be Vietnam Pro" pitchFamily="34" charset="-122"/>
                 <a:cs typeface="Be Vietnam Pro" pitchFamily="34" charset="-120"/>
               </a:rPr>
-              <a:t>chỉ</a:t>
-            </a:r>
-            <a:r>
-              <a:rPr lang="en-US" sz="1800" dirty="0" spc="-6" kern="0">
+              <a:t>thấy</a:t>
+            </a:r>
+            <a:r>
+              <a:rPr lang="en-US" sz="1800" dirty="0" spc="-4" kern="0">
                 <a:solidFill>
                   <a:srgbClr val="9A98A0"/>
                 </a:solidFill>
@@ -2494,10 +2494,10 @@
                 <a:ea typeface="Be Vietnam Pro" pitchFamily="34" charset="-122"/>
                 <a:cs typeface="Be Vietnam Pro" pitchFamily="34" charset="-120"/>
               </a:rPr>
-              <a:t> thấy</a:t>
-            </a:r>
-            <a:r>
-              <a:rPr lang="en-US" sz="1800" dirty="0" spc="-3" kern="0">
+              <a:t> bạn</a:t>
+            </a:r>
+            <a:r>
+              <a:rPr lang="en-US" sz="1800" dirty="0" spc="-1" kern="0">
                 <a:solidFill>
                   <a:srgbClr val="9A98A0"/>
                 </a:solidFill>
@@ -2505,40 +2505,73 @@
                 <a:ea typeface="Be Vietnam Pro" pitchFamily="34" charset="-122"/>
                 <a:cs typeface="Be Vietnam Pro" pitchFamily="34" charset="-120"/>
               </a:rPr>
+              <a:t> nối</a:t>
+            </a:r>
+            <a:r>
+              <a:rPr lang="en-US" sz="1800" dirty="0" spc="-10" kern="0">
+                <a:solidFill>
+                  <a:srgbClr val="9A98A0"/>
+                </a:solidFill>
+                <a:latin typeface="Be Vietnam Pro" pitchFamily="34" charset="0"/>
+                <a:ea typeface="Be Vietnam Pro" pitchFamily="34" charset="-122"/>
+                <a:cs typeface="Be Vietnam Pro" pitchFamily="34" charset="-120"/>
+              </a:rPr>
+              <a:t> tới</a:t>
+            </a:r>
+            <a:r>
+              <a:rPr lang="en-US" sz="1800" dirty="0" spc="-1" kern="0">
+                <a:solidFill>
+                  <a:srgbClr val="9A98A0"/>
+                </a:solidFill>
+                <a:latin typeface="Be Vietnam Pro" pitchFamily="34" charset="0"/>
+                <a:ea typeface="Be Vietnam Pro" pitchFamily="34" charset="-122"/>
+                <a:cs typeface="Be Vietnam Pro" pitchFamily="34" charset="-120"/>
+              </a:rPr>
+              <a:t> VPN,</a:t>
+            </a:r>
+            <a:r>
+              <a:rPr lang="en-US" sz="1800" dirty="0" spc="-2" kern="0">
+                <a:solidFill>
+                  <a:srgbClr val="9A98A0"/>
+                </a:solidFill>
+                <a:latin typeface="Be Vietnam Pro" pitchFamily="34" charset="0"/>
+                <a:ea typeface="Be Vietnam Pro" pitchFamily="34" charset="-122"/>
+                <a:cs typeface="Be Vietnam Pro" pitchFamily="34" charset="-120"/>
+              </a:rPr>
+              <a:t> không</a:t>
+            </a:r>
+            <a:r>
+              <a:rPr lang="en-US" sz="1800" dirty="0" spc="8" kern="0">
+                <a:solidFill>
+                  <a:srgbClr val="9A98A0"/>
+                </a:solidFill>
+                <a:latin typeface="Be Vietnam Pro" pitchFamily="34" charset="0"/>
+                <a:ea typeface="Be Vietnam Pro" pitchFamily="34" charset="-122"/>
+                <a:cs typeface="Be Vietnam Pro" pitchFamily="34" charset="-120"/>
+              </a:rPr>
+              <a:t> đọc</a:t>
+            </a:r>
+            <a:r>
+              <a:rPr lang="en-US" sz="1800" dirty="0" spc="7" kern="0">
+                <a:solidFill>
+                  <a:srgbClr val="9A98A0"/>
+                </a:solidFill>
+                <a:latin typeface="Be Vietnam Pro" pitchFamily="34" charset="0"/>
+                <a:ea typeface="Be Vietnam Pro" pitchFamily="34" charset="-122"/>
+                <a:cs typeface="Be Vietnam Pro" pitchFamily="34" charset="-120"/>
+              </a:rPr>
+              <a:t> được</a:t>
+            </a:r>
+            <a:r>
+              <a:rPr lang="en-US" sz="1800" dirty="0" spc="-2" kern="0">
+                <a:solidFill>
+                  <a:srgbClr val="9A98A0"/>
+                </a:solidFill>
+                <a:latin typeface="Be Vietnam Pro" pitchFamily="34" charset="0"/>
+                <a:ea typeface="Be Vietnam Pro" pitchFamily="34" charset="-122"/>
+                <a:cs typeface="Be Vietnam Pro" pitchFamily="34" charset="-120"/>
+              </a:rPr>
               <a:t> tin</a:t>
-            </a:r>
-            <a:r>
-              <a:rPr lang="en-US" sz="1800" dirty="0" spc="15" kern="0">
-                <a:solidFill>
-                  <a:srgbClr val="9A98A0"/>
-                </a:solidFill>
-                <a:latin typeface="Be Vietnam Pro" pitchFamily="34" charset="0"/>
-                <a:ea typeface="Be Vietnam Pro" pitchFamily="34" charset="-122"/>
-                <a:cs typeface="Be Vietnam Pro" pitchFamily="34" charset="-120"/>
-              </a:rPr>
-              <a:t> đã</a:t>
-            </a:r>
-            <a:r>
-              <a:rPr lang="en-US" sz="1800" dirty="0" spc="-2" kern="0">
-                <a:solidFill>
-                  <a:srgbClr val="9A98A0"/>
-                </a:solidFill>
-                <a:latin typeface="Be Vietnam Pro" pitchFamily="34" charset="0"/>
-                <a:ea typeface="Be Vietnam Pro" pitchFamily="34" charset="-122"/>
-                <a:cs typeface="Be Vietnam Pro" pitchFamily="34" charset="-120"/>
-              </a:rPr>
-              <a:t> mã</a:t>
-            </a:r>
-            <a:r>
-              <a:rPr lang="en-US" sz="1800" dirty="0" spc="-1" kern="0">
-                <a:solidFill>
-                  <a:srgbClr val="9A98A0"/>
-                </a:solidFill>
-                <a:latin typeface="Be Vietnam Pro" pitchFamily="34" charset="0"/>
-                <a:ea typeface="Be Vietnam Pro" pitchFamily="34" charset="-122"/>
-                <a:cs typeface="Be Vietnam Pro" pitchFamily="34" charset="-120"/>
-              </a:rPr>
-              <a:t> hóa</a:t>
             </a:r>
             <a:endParaRPr lang="en-US" sz="1800" dirty="0"/>
           </a:p>
@@ -3257,7 +3290,7 @@
       </p:sp>
       <p:sp>
         <p:nvSpPr>
-          <p:cNvPr id="26" name="Connector line-1792370920869-504848481"/>
+          <p:cNvPr id="26" name="Connector line-1792405368142-998700976"/>
           <p:cNvSpPr/>
           <p:nvPr/>
         </p:nvSpPr>
@@ -3282,7 +3315,7 @@
       </p:sp>
       <p:sp>
         <p:nvSpPr>
-          <p:cNvPr id="27" name="Connector line-1792370920870-840408569"/>
+          <p:cNvPr id="27" name="Connector line-1792405368143-687616542"/>
           <p:cNvSpPr/>
           <p:nvPr/>
         </p:nvSpPr>
@@ -3307,7 +3340,7 @@
       </p:sp>
       <p:sp>
         <p:nvSpPr>
-          <p:cNvPr id="28" name="Connector line-1792370920870-218961170"/>
+          <p:cNvPr id="28" name="Connector line-1792405368143-438758283"/>
           <p:cNvSpPr/>
           <p:nvPr/>
         </p:nvSpPr>
@@ -3617,6 +3650,17 @@
               </a:rPr>
               <a:t> được</a:t>
             </a:r>
+            <a:r>
+              <a:rPr lang="en-US" sz="1800" dirty="0" spc="2" kern="0">
+                <a:solidFill>
+                  <a:srgbClr val="FFB454"/>
+                </a:solidFill>
+                <a:latin typeface="Be Vietnam Pro SemiBold" pitchFamily="34" charset="0"/>
+                <a:ea typeface="Be Vietnam Pro SemiBold" pitchFamily="34" charset="-122"/>
+                <a:cs typeface="Be Vietnam Pro SemiBold" pitchFamily="34" charset="-120"/>
+              </a:rPr>
+              <a:t> tin</a:t>
+            </a:r>
             <a:endParaRPr lang="en-US" sz="1800" dirty="0"/>
           </a:p>
         </p:txBody>
@@ -3750,13 +3794,24 @@
               </a:rPr>
               <a:t> được</a:t>
             </a:r>
+            <a:r>
+              <a:rPr lang="en-US" sz="1800" dirty="0" spc="2" kern="0">
+                <a:solidFill>
+                  <a:srgbClr val="FFB454"/>
+                </a:solidFill>
+                <a:latin typeface="Be Vietnam Pro SemiBold" pitchFamily="34" charset="0"/>
+                <a:ea typeface="Be Vietnam Pro SemiBold" pitchFamily="34" charset="-122"/>
+                <a:cs typeface="Be Vietnam Pro SemiBold" pitchFamily="34" charset="-120"/>
+              </a:rPr>
+              <a:t> tin</a:t>
+            </a:r>
             <a:endParaRPr lang="en-US" sz="1800" dirty="0"/>
           </a:p>
         </p:txBody>
       </p:sp>
       <p:sp>
         <p:nvSpPr>
-          <p:cNvPr id="39" name="Connector line-1792370920883-407632538"/>
+          <p:cNvPr id="39" name="Connector line-1792405368152-644715342"/>
           <p:cNvSpPr/>
           <p:nvPr/>
         </p:nvSpPr>
@@ -13307,7 +13362,7 @@
       </p:sp>
       <p:sp>
         <p:nvSpPr>
-          <p:cNvPr id="23" name="Connector line-1792378674311-157474706"/>
+          <p:cNvPr id="23" name="Connector line-1792405191356-363154529"/>
           <p:cNvSpPr/>
           <p:nvPr/>
         </p:nvSpPr>
@@ -13368,7 +13423,7 @@
           <a:ln/>
         </p:spPr>
         <p:txBody>
-          <a:bodyPr wrap="square" lIns="0" tIns="0" rIns="0" bIns="0" rtlCol="0" anchor="t"/>
+          <a:bodyPr wrap="square" lIns="0" tIns="0" rIns="0" bIns="0" rtlCol="0" anchor="ctr"/>
           <a:lstStyle/>
           <a:p>
             <a:pPr algn="l" indent="0" marL="0">
@@ -13430,6 +13485,28 @@
               <a:t> nối</a:t>
             </a:r>
             <a:r>
+              <a:rPr lang="en-US" sz="2550" b="1" dirty="0" spc="-1" kern="0">
+                <a:solidFill>
+                  <a:srgbClr val="14161C"/>
+                </a:solidFill>
+                <a:latin typeface="Be Vietnam Pro" pitchFamily="34" charset="0"/>
+                <a:ea typeface="Be Vietnam Pro" pitchFamily="34" charset="-122"/>
+                <a:cs typeface="Be Vietnam Pro" pitchFamily="34" charset="-120"/>
+              </a:rPr>
+              <a:t> từ</a:t>
+            </a:r>
+            <a:r>
+              <a:rPr lang="en-US" sz="2550" b="1" dirty="0" spc="0" kern="0">
+                <a:solidFill>
+                  <a:srgbClr val="14161C"/>
+                </a:solidFill>
+                <a:latin typeface="Be Vietnam Pro" pitchFamily="34" charset="0"/>
+                <a:ea typeface="Be Vietnam Pro" pitchFamily="34" charset="-122"/>
+                <a:cs typeface="Be Vietnam Pro" pitchFamily="34" charset="-120"/>
+              </a:rPr>
+              <a:t> bạn</a:t>
+            </a:r>
+            <a:r>
               <a:rPr lang="en-US" sz="2550" b="1" dirty="0" spc="3" kern="0">
                 <a:solidFill>
                   <a:srgbClr val="14161C"/>
@@ -13452,7 +13529,7 @@
               <a:t> máy</a:t>
             </a:r>
             <a:r>
-              <a:rPr lang="en-US" sz="2550" b="1" dirty="0" spc="-1" kern="0">
+              <a:rPr lang="en-US" sz="2550" b="1" dirty="0" spc="0" kern="0">
                 <a:solidFill>
                   <a:srgbClr val="14161C"/>
                 </a:solidFill>
@@ -13463,7 +13540,7 @@
               <a:t> chủ</a:t>
             </a:r>
             <a:r>
-              <a:rPr lang="en-US" sz="2550" b="1" dirty="0" spc="-2" kern="0">
+              <a:rPr lang="en-US" sz="2550" b="1" dirty="0" spc="-3" kern="0">
                 <a:solidFill>
                   <a:srgbClr val="14161C"/>
                 </a:solidFill>
@@ -14201,7 +14278,7 @@
       </p:sp>
       <p:sp>
         <p:nvSpPr>
-          <p:cNvPr id="33" name="Connector line-1792378674329-629618574"/>
+          <p:cNvPr id="33" name="Connector line-1792405191369-253721455"/>
           <p:cNvSpPr/>
           <p:nvPr/>
         </p:nvSpPr>
@@ -14930,7 +15007,7 @@
       </p:sp>
       <p:sp>
         <p:nvSpPr>
-          <p:cNvPr id="8" name="Connector line-1792378802294-67549781"/>
+          <p:cNvPr id="8" name="Connector line-1792405982957-727898929"/>
           <p:cNvSpPr/>
           <p:nvPr/>
         </p:nvSpPr>
@@ -15513,7 +15590,7 @@
       </p:sp>
       <p:sp>
         <p:nvSpPr>
-          <p:cNvPr id="19" name="Connector line-1792378802307-119824642"/>
+          <p:cNvPr id="19" name="Connector line-1792405982971-883587258"/>
           <p:cNvSpPr/>
           <p:nvPr/>
         </p:nvSpPr>
@@ -15955,7 +16032,7 @@
       </p:sp>
       <p:sp>
         <p:nvSpPr>
-          <p:cNvPr id="29" name="Connector line-1792378802315-975588418"/>
+          <p:cNvPr id="29" name="Connector line-1792405982980-616868198"/>
           <p:cNvSpPr/>
           <p:nvPr/>
         </p:nvSpPr>
@@ -16033,7 +16110,40 @@
                 <a:ea typeface="Be Vietnam Pro" pitchFamily="34" charset="-122"/>
                 <a:cs typeface="Be Vietnam Pro" pitchFamily="34" charset="-120"/>
               </a:rPr>
-              <a:t> được nữa</a:t>
+              <a:t> được</a:t>
+            </a:r>
+            <a:r>
+              <a:rPr lang="en-US" sz="1800" dirty="0" spc="-3" kern="0">
+                <a:solidFill>
+                  <a:srgbClr val="D8D3C4"/>
+                </a:solidFill>
+                <a:latin typeface="Be Vietnam Pro" pitchFamily="34" charset="0"/>
+                <a:ea typeface="Be Vietnam Pro" pitchFamily="34" charset="-122"/>
+                <a:cs typeface="Be Vietnam Pro" pitchFamily="34" charset="-120"/>
+              </a:rPr>
+              <a:t> tin</a:t>
+            </a:r>
+            <a:r>
+              <a:rPr lang="en-US" sz="1800" dirty="0" spc="-11" kern="0">
+                <a:solidFill>
+                  <a:srgbClr val="D8D3C4"/>
+                </a:solidFill>
+                <a:latin typeface="Be Vietnam Pro" pitchFamily="34" charset="0"/>
+                <a:ea typeface="Be Vietnam Pro" pitchFamily="34" charset="-122"/>
+                <a:cs typeface="Be Vietnam Pro" pitchFamily="34" charset="-120"/>
+              </a:rPr>
+              <a:t> gốc</a:t>
+            </a:r>
+            <a:r>
+              <a:rPr lang="en-US" sz="1800" dirty="0" spc="7" kern="0">
+                <a:solidFill>
+                  <a:srgbClr val="D8D3C4"/>
+                </a:solidFill>
+                <a:latin typeface="Be Vietnam Pro" pitchFamily="34" charset="0"/>
+                <a:ea typeface="Be Vietnam Pro" pitchFamily="34" charset="-122"/>
+                <a:cs typeface="Be Vietnam Pro" pitchFamily="34" charset="-120"/>
+              </a:rPr>
+              <a:t> nữa</a:t>
             </a:r>
             <a:endParaRPr lang="en-US" sz="1800" dirty="0"/>
           </a:p>
@@ -16041,7 +16151,7 @@
       </p:sp>
       <p:sp>
         <p:nvSpPr>
-          <p:cNvPr id="31" name="Connector line-1792378802316-155726499"/>
+          <p:cNvPr id="31" name="Connector line-1792405982982-902689274"/>
           <p:cNvSpPr/>
           <p:nvPr/>
         </p:nvSpPr>
@@ -16804,7 +16914,7 @@
       </p:sp>
       <p:sp>
         <p:nvSpPr>
-          <p:cNvPr id="41" name="Connector line-1792378802326-292476838"/>
+          <p:cNvPr id="41" name="Connector line-1792405982992-522860514"/>
           <p:cNvSpPr/>
           <p:nvPr/>
         </p:nvSpPr>
@@ -20350,12 +20460,12 @@
         </p:nvSpPr>
         <p:spPr>
           <a:xfrm>
-            <a:off x="914400" y="2819400"/>
-            <a:ext cx="8115300" cy="1809750"/>
+            <a:off x="914400" y="2762250"/>
+            <a:ext cx="8115300" cy="2019300"/>
           </a:xfrm>
           <a:prstGeom prst="roundRect">
             <a:avLst>
-              <a:gd name="adj" fmla="val 13684"/>
+              <a:gd name="adj" fmla="val 12264"/>
             </a:avLst>
           </a:prstGeom>
           <a:solidFill>
@@ -20377,7 +20487,7 @@
         </p:nvSpPr>
         <p:spPr>
           <a:xfrm>
-            <a:off x="1219200" y="3028950"/>
+            <a:off x="1219200" y="2971800"/>
             <a:ext cx="7429500" cy="266700"/>
           </a:xfrm>
           <a:prstGeom prst="rect">
@@ -20427,7 +20537,7 @@
         </p:nvSpPr>
         <p:spPr>
           <a:xfrm>
-            <a:off x="1219200" y="3390900"/>
+            <a:off x="1219200" y="3314700"/>
             <a:ext cx="7429500" cy="495300"/>
           </a:xfrm>
           <a:prstGeom prst="rect">
@@ -20437,7 +20547,7 @@
           <a:ln/>
         </p:spPr>
         <p:txBody>
-          <a:bodyPr wrap="square" lIns="0" tIns="0" rIns="0" bIns="0" rtlCol="0" anchor="t"/>
+          <a:bodyPr wrap="square" lIns="0" tIns="0" rIns="0" bIns="0" rtlCol="0" anchor="ctr"/>
           <a:lstStyle/>
           <a:p>
             <a:pPr algn="l" indent="0" marL="0">
@@ -20509,6 +20619,39 @@
               </a:rPr>
               <a:t> thật</a:t>
             </a:r>
+            <a:r>
+              <a:rPr lang="en-US" sz="2850" b="1" dirty="0" spc="3" kern="0">
+                <a:solidFill>
+                  <a:srgbClr val="F3EEE3"/>
+                </a:solidFill>
+                <a:latin typeface="Be Vietnam Pro" pitchFamily="34" charset="0"/>
+                <a:ea typeface="Be Vietnam Pro" pitchFamily="34" charset="-122"/>
+                <a:cs typeface="Be Vietnam Pro" pitchFamily="34" charset="-120"/>
+              </a:rPr>
+              <a:t> ở</a:t>
+            </a:r>
+            <a:r>
+              <a:rPr lang="en-US" sz="2850" b="1" dirty="0" spc="12" kern="0">
+                <a:solidFill>
+                  <a:srgbClr val="F3EEE3"/>
+                </a:solidFill>
+                <a:latin typeface="Be Vietnam Pro" pitchFamily="34" charset="0"/>
+                <a:ea typeface="Be Vietnam Pro" pitchFamily="34" charset="-122"/>
+                <a:cs typeface="Be Vietnam Pro" pitchFamily="34" charset="-120"/>
+              </a:rPr>
+              <a:t> đầu</a:t>
+            </a:r>
+            <a:r>
+              <a:rPr lang="en-US" sz="2850" b="1" dirty="0" spc="2" kern="0">
+                <a:solidFill>
+                  <a:srgbClr val="F3EEE3"/>
+                </a:solidFill>
+                <a:latin typeface="Be Vietnam Pro" pitchFamily="34" charset="0"/>
+                <a:ea typeface="Be Vietnam Pro" pitchFamily="34" charset="-122"/>
+                <a:cs typeface="Be Vietnam Pro" pitchFamily="34" charset="-120"/>
+              </a:rPr>
+              <a:t> kia</a:t>
+            </a:r>
             <a:endParaRPr lang="en-US" sz="2850" dirty="0"/>
           </a:p>
         </p:txBody>
@@ -20521,8 +20664,8 @@
         </p:nvSpPr>
         <p:spPr>
           <a:xfrm>
-            <a:off x="1219200" y="4019550"/>
-            <a:ext cx="7429500" cy="381000"/>
+            <a:off x="1219200" y="3905250"/>
+            <a:ext cx="7429500" cy="800100"/>
           </a:xfrm>
           <a:prstGeom prst="rect">
             <a:avLst/>
@@ -20531,14 +20674,17 @@
           <a:ln/>
         </p:spPr>
         <p:txBody>
-          <a:bodyPr wrap="square" lIns="0" tIns="0" rIns="0" bIns="0" rtlCol="0" anchor="t"/>
+          <a:bodyPr wrap="square" lIns="0" tIns="11335" rIns="0" bIns="-11335" rtlCol="0" anchor="t"/>
           <a:lstStyle/>
           <a:p>
             <a:pPr algn="l" indent="0" marL="0">
+              <a:lnSpc>
+                <a:spcPts val="2730"/>
+              </a:lnSpc>
               <a:buNone/>
             </a:pPr>
             <a:r>
-              <a:rPr lang="en-US" sz="2100" dirty="0" spc="1" kern="0">
+              <a:rPr lang="en-US" sz="2100" dirty="0" spc="-17" kern="0">
                 <a:solidFill>
                   <a:srgbClr val="D8D3C4"/>
                 </a:solidFill>
@@ -20546,10 +20692,10 @@
                 <a:ea typeface="Be Vietnam Pro" pitchFamily="34" charset="-122"/>
                 <a:cs typeface="Be Vietnam Pro" pitchFamily="34" charset="-120"/>
               </a:rPr>
-              <a:t>từ</a:t>
-            </a:r>
-            <a:r>
-              <a:rPr lang="en-US" sz="2100" dirty="0" spc="4" kern="0">
+              <a:t>trang</a:t>
+            </a:r>
+            <a:r>
+              <a:rPr lang="en-US" sz="2100" dirty="0" spc="-8" kern="0">
                 <a:solidFill>
                   <a:srgbClr val="D8D3C4"/>
                 </a:solidFill>
@@ -20557,10 +20703,54 @@
                 <a:ea typeface="Be Vietnam Pro" pitchFamily="34" charset="-122"/>
                 <a:cs typeface="Be Vietnam Pro" pitchFamily="34" charset="-120"/>
               </a:rPr>
+              <a:t> thấy</a:t>
+            </a:r>
+            <a:r>
+              <a:rPr lang="en-US" sz="2100" dirty="0" spc="-11" kern="0">
+                <a:solidFill>
+                  <a:srgbClr val="D8D3C4"/>
+                </a:solidFill>
+                <a:latin typeface="Be Vietnam Pro" pitchFamily="34" charset="0"/>
+                <a:ea typeface="Be Vietnam Pro" pitchFamily="34" charset="-122"/>
+                <a:cs typeface="Be Vietnam Pro" pitchFamily="34" charset="-120"/>
+              </a:rPr>
+              <a:t> máy</a:t>
+            </a:r>
+            <a:r>
+              <a:rPr lang="en-US" sz="2100" dirty="0" spc="0" kern="0">
+                <a:solidFill>
+                  <a:srgbClr val="D8D3C4"/>
+                </a:solidFill>
+                <a:latin typeface="Be Vietnam Pro" pitchFamily="34" charset="0"/>
+                <a:ea typeface="Be Vietnam Pro" pitchFamily="34" charset="-122"/>
+                <a:cs typeface="Be Vietnam Pro" pitchFamily="34" charset="-120"/>
+              </a:rPr>
+              <a:t> chủ</a:t>
+            </a:r>
+            <a:r>
+              <a:rPr lang="en-US" sz="2100" dirty="0" spc="-2" kern="0">
+                <a:solidFill>
+                  <a:srgbClr val="D8D3C4"/>
+                </a:solidFill>
+                <a:latin typeface="Be Vietnam Pro" pitchFamily="34" charset="0"/>
+                <a:ea typeface="Be Vietnam Pro" pitchFamily="34" charset="-122"/>
+                <a:cs typeface="Be Vietnam Pro" pitchFamily="34" charset="-120"/>
+              </a:rPr>
+              <a:t> VPN;</a:t>
+            </a:r>
+            <a:r>
+              <a:rPr lang="en-US" sz="2100" dirty="0" spc="5" kern="0">
+                <a:solidFill>
+                  <a:srgbClr val="D8D3C4"/>
+                </a:solidFill>
+                <a:latin typeface="Be Vietnam Pro" pitchFamily="34" charset="0"/>
+                <a:ea typeface="Be Vietnam Pro" pitchFamily="34" charset="-122"/>
+                <a:cs typeface="Be Vietnam Pro" pitchFamily="34" charset="-120"/>
+              </a:rPr>
               <a:t> người</a:t>
             </a:r>
             <a:r>
-              <a:rPr lang="en-US" sz="2100" dirty="0" spc="-1" kern="0">
+              <a:rPr lang="en-US" sz="2100" dirty="0" spc="-2" kern="0">
                 <a:solidFill>
                   <a:srgbClr val="D8D3C4"/>
                 </a:solidFill>
@@ -20571,7 +20761,7 @@
               <a:t> nghe</a:t>
             </a:r>
             <a:r>
-              <a:rPr lang="en-US" sz="2100" dirty="0" spc="-17" kern="0">
+              <a:rPr lang="en-US" sz="2100" dirty="0" spc="-12" kern="0">
                 <a:solidFill>
                   <a:srgbClr val="D8D3C4"/>
                 </a:solidFill>
@@ -20579,10 +20769,10 @@
                 <a:ea typeface="Be Vietnam Pro" pitchFamily="34" charset="-122"/>
                 <a:cs typeface="Be Vietnam Pro" pitchFamily="34" charset="-120"/>
               </a:rPr>
-              <a:t> và</a:t>
-            </a:r>
-            <a:r>
-              <a:rPr lang="en-US" sz="2100" dirty="0" spc="-15" kern="0">
+              <a:t> vẫn</a:t>
+            </a:r>
+            <a:r>
+              <a:rPr lang="en-US" sz="2100" dirty="0" spc="-9" kern="0">
                 <a:solidFill>
                   <a:srgbClr val="D8D3C4"/>
                 </a:solidFill>
@@ -20590,10 +20780,10 @@
                 <a:ea typeface="Be Vietnam Pro" pitchFamily="34" charset="-122"/>
                 <a:cs typeface="Be Vietnam Pro" pitchFamily="34" charset="-120"/>
               </a:rPr>
-              <a:t> trang</a:t>
-            </a:r>
-            <a:r>
-              <a:rPr lang="en-US" sz="2100" dirty="0" spc="-14" kern="0">
+              <a:t> thấy</a:t>
+            </a:r>
+            <a:r>
+              <a:rPr lang="en-US" sz="2100" dirty="0" spc="-5" kern="0">
                 <a:solidFill>
                   <a:srgbClr val="D8D3C4"/>
                 </a:solidFill>
@@ -20601,10 +20791,10 @@
                 <a:ea typeface="Be Vietnam Pro" pitchFamily="34" charset="-122"/>
                 <a:cs typeface="Be Vietnam Pro" pitchFamily="34" charset="-120"/>
               </a:rPr>
-              <a:t> web</a:t>
-            </a:r>
-            <a:r>
-              <a:rPr lang="en-US" sz="2100" dirty="0" spc="-4" kern="0">
+              <a:t> bạn</a:t>
+            </a:r>
+            <a:r>
+              <a:rPr lang="en-US" sz="2100" dirty="0" spc="0" kern="0">
                 <a:solidFill>
                   <a:srgbClr val="D8D3C4"/>
                 </a:solidFill>
@@ -20612,7 +20802,18 @@
                 <a:ea typeface="Be Vietnam Pro" pitchFamily="34" charset="-122"/>
                 <a:cs typeface="Be Vietnam Pro" pitchFamily="34" charset="-120"/>
               </a:rPr>
-              <a:t> sang</a:t>
+              <a:t> nối</a:t>
+            </a:r>
+            <a:r>
+              <a:rPr lang="en-US" sz="2100" dirty="0" spc="-13" kern="0">
+                <a:solidFill>
+                  <a:srgbClr val="D8D3C4"/>
+                </a:solidFill>
+                <a:latin typeface="Be Vietnam Pro" pitchFamily="34" charset="0"/>
+                <a:ea typeface="Be Vietnam Pro" pitchFamily="34" charset="-122"/>
+                <a:cs typeface="Be Vietnam Pro" pitchFamily="34" charset="-120"/>
+              </a:rPr>
+              <a:t> tới</a:t>
             </a:r>
             <a:r>
               <a:rPr lang="en-US" sz="2100" dirty="0" spc="-10" kern="0">
@@ -20659,12 +20860,12 @@
         </p:nvSpPr>
         <p:spPr>
           <a:xfrm>
-            <a:off x="9258300" y="2819400"/>
-            <a:ext cx="8115300" cy="1809750"/>
+            <a:off x="9258300" y="2762250"/>
+            <a:ext cx="8115300" cy="2019300"/>
           </a:xfrm>
           <a:prstGeom prst="roundRect">
             <a:avLst>
-              <a:gd name="adj" fmla="val 13684"/>
+              <a:gd name="adj" fmla="val 12264"/>
             </a:avLst>
           </a:prstGeom>
           <a:solidFill>
@@ -20686,7 +20887,7 @@
         </p:nvSpPr>
         <p:spPr>
           <a:xfrm>
-            <a:off x="9563100" y="3028950"/>
+            <a:off x="9563100" y="2971800"/>
             <a:ext cx="7429500" cy="266700"/>
           </a:xfrm>
           <a:prstGeom prst="rect">
@@ -20725,7 +20926,7 @@
         </p:nvSpPr>
         <p:spPr>
           <a:xfrm>
-            <a:off x="9563100" y="3390900"/>
+            <a:off x="9563100" y="3314700"/>
             <a:ext cx="7429500" cy="495300"/>
           </a:xfrm>
           <a:prstGeom prst="rect">
@@ -20735,7 +20936,7 @@
           <a:ln/>
         </p:spPr>
         <p:txBody>
-          <a:bodyPr wrap="square" lIns="0" tIns="0" rIns="0" bIns="0" rtlCol="0" anchor="t"/>
+          <a:bodyPr wrap="square" lIns="0" tIns="0" rIns="0" bIns="0" rtlCol="0" anchor="ctr"/>
           <a:lstStyle/>
           <a:p>
             <a:pPr algn="l" indent="0" marL="0">
@@ -20808,8 +21009,8 @@
         </p:nvSpPr>
         <p:spPr>
           <a:xfrm>
-            <a:off x="9563100" y="4019550"/>
-            <a:ext cx="7429500" cy="381000"/>
+            <a:off x="9563100" y="3905250"/>
+            <a:ext cx="7429500" cy="800100"/>
           </a:xfrm>
           <a:prstGeom prst="rect">
             <a:avLst/>
@@ -20818,10 +21019,13 @@
           <a:ln/>
         </p:spPr>
         <p:txBody>
-          <a:bodyPr wrap="square" lIns="0" tIns="0" rIns="0" bIns="0" rtlCol="0" anchor="t"/>
+          <a:bodyPr wrap="square" lIns="0" tIns="11335" rIns="0" bIns="-11335" rtlCol="0" anchor="t"/>
           <a:lstStyle/>
           <a:p>
             <a:pPr algn="l" indent="0" marL="0">
+              <a:lnSpc>
+                <a:spcPts val="2730"/>
+              </a:lnSpc>
               <a:buNone/>
             </a:pPr>
             <a:r>
@@ -20924,7 +21128,7 @@
         </p:nvSpPr>
         <p:spPr>
           <a:xfrm>
-            <a:off x="914400" y="4857750"/>
+            <a:off x="914400" y="4991100"/>
             <a:ext cx="8115300" cy="2495550"/>
           </a:xfrm>
           <a:prstGeom prst="roundRect">
@@ -20951,7 +21155,7 @@
         </p:nvSpPr>
         <p:spPr>
           <a:xfrm>
-            <a:off x="1219200" y="5067300"/>
+            <a:off x="1219200" y="5200650"/>
             <a:ext cx="7429500" cy="266700"/>
           </a:xfrm>
           <a:prstGeom prst="rect">
@@ -21023,7 +21227,7 @@
         </p:nvSpPr>
         <p:spPr>
           <a:xfrm>
-            <a:off x="1219200" y="5429250"/>
+            <a:off x="1219200" y="5543550"/>
             <a:ext cx="7429500" cy="495300"/>
           </a:xfrm>
           <a:prstGeom prst="rect">
@@ -21033,7 +21237,7 @@
           <a:ln/>
         </p:spPr>
         <p:txBody>
-          <a:bodyPr wrap="square" lIns="0" tIns="0" rIns="0" bIns="0" rtlCol="0" anchor="t"/>
+          <a:bodyPr wrap="square" lIns="0" tIns="0" rIns="0" bIns="0" rtlCol="0" anchor="ctr"/>
           <a:lstStyle/>
           <a:p>
             <a:pPr algn="l" indent="0" marL="0">
@@ -21111,13 +21315,13 @@
       </p:sp>
       <p:sp>
         <p:nvSpPr>
-          <p:cNvPr id="15" name="Text richtext-1792383331666-613357305"/>
-          <p:cNvSpPr/>
-          <p:nvPr/>
-        </p:nvSpPr>
-        <p:spPr>
-          <a:xfrm>
-            <a:off x="1219200" y="6000750"/>
+          <p:cNvPr id="15" name="Text richtext-1792405069900-754417359"/>
+          <p:cNvSpPr/>
+          <p:nvPr/>
+        </p:nvSpPr>
+        <p:spPr>
+          <a:xfrm>
+            <a:off x="1219200" y="6134100"/>
             <a:ext cx="7429500" cy="1276350"/>
           </a:xfrm>
           <a:prstGeom prst="rect">
@@ -21409,7 +21613,7 @@
         </p:nvSpPr>
         <p:spPr>
           <a:xfrm>
-            <a:off x="9258300" y="4857750"/>
+            <a:off x="9258300" y="4991100"/>
             <a:ext cx="8115300" cy="2495550"/>
           </a:xfrm>
           <a:prstGeom prst="roundRect">
@@ -21436,7 +21640,7 @@
         </p:nvSpPr>
         <p:spPr>
           <a:xfrm>
-            <a:off x="9563100" y="5067300"/>
+            <a:off x="9563100" y="5200650"/>
             <a:ext cx="7429500" cy="266700"/>
           </a:xfrm>
           <a:prstGeom prst="rect">
@@ -21497,7 +21701,7 @@
         </p:nvSpPr>
         <p:spPr>
           <a:xfrm>
-            <a:off x="9563100" y="5429250"/>
+            <a:off x="9563100" y="5543550"/>
             <a:ext cx="7429500" cy="495300"/>
           </a:xfrm>
           <a:prstGeom prst="rect">
@@ -21507,7 +21711,7 @@
           <a:ln/>
         </p:spPr>
         <p:txBody>
-          <a:bodyPr wrap="square" lIns="0" tIns="0" rIns="0" bIns="0" rtlCol="0" anchor="t"/>
+          <a:bodyPr wrap="square" lIns="0" tIns="0" rIns="0" bIns="0" rtlCol="0" anchor="ctr"/>
           <a:lstStyle/>
           <a:p>
             <a:pPr algn="l" indent="0" marL="0">
@@ -21569,7 +21773,7 @@
         </p:nvSpPr>
         <p:spPr>
           <a:xfrm>
-            <a:off x="9563100" y="6057900"/>
+            <a:off x="9563100" y="6172200"/>
             <a:ext cx="7429500" cy="952500"/>
           </a:xfrm>
           <a:prstGeom prst="rect">
@@ -21699,12 +21903,12 @@
         </p:nvSpPr>
         <p:spPr>
           <a:xfrm>
-            <a:off x="914400" y="7620000"/>
-            <a:ext cx="16459200" cy="1428750"/>
+            <a:off x="914400" y="7696200"/>
+            <a:ext cx="16459200" cy="1447800"/>
           </a:xfrm>
           <a:prstGeom prst="roundRect">
             <a:avLst>
-              <a:gd name="adj" fmla="val 17333"/>
+              <a:gd name="adj" fmla="val 17105"/>
             </a:avLst>
           </a:prstGeom>
           <a:solidFill>
@@ -21726,8 +21930,485 @@
         </p:nvSpPr>
         <p:spPr>
           <a:xfrm>
-            <a:off x="1238250" y="7829550"/>
-            <a:ext cx="15811500" cy="533400"/>
+            <a:off x="1238250" y="7867650"/>
+            <a:ext cx="15811500" cy="476250"/>
+          </a:xfrm>
+          <a:prstGeom prst="rect">
+            <a:avLst/>
+          </a:prstGeom>
+          <a:noFill/>
+          <a:ln/>
+        </p:spPr>
+        <p:txBody>
+          <a:bodyPr wrap="square" lIns="0" tIns="0" rIns="0" bIns="0" rtlCol="0" anchor="ctr"/>
+          <a:lstStyle/>
+          <a:p>
+            <a:pPr algn="l" indent="0" marL="0">
+              <a:buNone/>
+            </a:pPr>
+            <a:r>
+              <a:rPr lang="en-US" sz="2700" b="1" dirty="0" spc="-4" kern="0">
+                <a:solidFill>
+                  <a:srgbClr val="FF6A4D"/>
+                </a:solidFill>
+                <a:latin typeface="Be Vietnam Pro" pitchFamily="34" charset="0"/>
+                <a:ea typeface="Be Vietnam Pro" pitchFamily="34" charset="-122"/>
+                <a:cs typeface="Be Vietnam Pro" pitchFamily="34" charset="-120"/>
+              </a:rPr>
+              <a:t>“Riêng</a:t>
+            </a:r>
+            <a:r>
+              <a:rPr lang="en-US" sz="2700" b="1" dirty="0" spc="-1" kern="0">
+                <a:solidFill>
+                  <a:srgbClr val="FF6A4D"/>
+                </a:solidFill>
+                <a:latin typeface="Be Vietnam Pro" pitchFamily="34" charset="0"/>
+                <a:ea typeface="Be Vietnam Pro" pitchFamily="34" charset="-122"/>
+                <a:cs typeface="Be Vietnam Pro" pitchFamily="34" charset="-120"/>
+              </a:rPr>
+              <a:t> tư”</a:t>
+            </a:r>
+            <a:r>
+              <a:rPr lang="en-US" sz="2700" b="1" dirty="0" spc="-23" kern="0">
+                <a:solidFill>
+                  <a:srgbClr val="FF6A4D"/>
+                </a:solidFill>
+                <a:latin typeface="Be Vietnam Pro" pitchFamily="34" charset="0"/>
+                <a:ea typeface="Be Vietnam Pro" pitchFamily="34" charset="-122"/>
+                <a:cs typeface="Be Vietnam Pro" pitchFamily="34" charset="-120"/>
+              </a:rPr>
+              <a:t> và</a:t>
+            </a:r>
+            <a:r>
+              <a:rPr lang="en-US" sz="2700" b="1" dirty="0" spc="2" kern="0">
+                <a:solidFill>
+                  <a:srgbClr val="FF6A4D"/>
+                </a:solidFill>
+                <a:latin typeface="Be Vietnam Pro" pitchFamily="34" charset="0"/>
+                <a:ea typeface="Be Vietnam Pro" pitchFamily="34" charset="-122"/>
+                <a:cs typeface="Be Vietnam Pro" pitchFamily="34" charset="-120"/>
+              </a:rPr>
+              <a:t> “ẩn</a:t>
+            </a:r>
+            <a:r>
+              <a:rPr lang="en-US" sz="2700" b="1" dirty="0" spc="1" kern="0">
+                <a:solidFill>
+                  <a:srgbClr val="FF6A4D"/>
+                </a:solidFill>
+                <a:latin typeface="Be Vietnam Pro" pitchFamily="34" charset="0"/>
+                <a:ea typeface="Be Vietnam Pro" pitchFamily="34" charset="-122"/>
+                <a:cs typeface="Be Vietnam Pro" pitchFamily="34" charset="-120"/>
+              </a:rPr>
+              <a:t> danh”</a:t>
+            </a:r>
+            <a:r>
+              <a:rPr lang="en-US" sz="2700" b="1" dirty="0" spc="0" kern="0">
+                <a:solidFill>
+                  <a:srgbClr val="FF6A4D"/>
+                </a:solidFill>
+                <a:latin typeface="Be Vietnam Pro" pitchFamily="34" charset="0"/>
+                <a:ea typeface="Be Vietnam Pro" pitchFamily="34" charset="-122"/>
+                <a:cs typeface="Be Vietnam Pro" pitchFamily="34" charset="-120"/>
+              </a:rPr>
+              <a:t> chỉ</a:t>
+            </a:r>
+            <a:r>
+              <a:rPr lang="en-US" sz="2700" b="1" dirty="0" spc="-4" kern="0">
+                <a:solidFill>
+                  <a:srgbClr val="FF6A4D"/>
+                </a:solidFill>
+                <a:latin typeface="Be Vietnam Pro" pitchFamily="34" charset="0"/>
+                <a:ea typeface="Be Vietnam Pro" pitchFamily="34" charset="-122"/>
+                <a:cs typeface="Be Vietnam Pro" pitchFamily="34" charset="-120"/>
+              </a:rPr>
+              <a:t> đúng</a:t>
+            </a:r>
+            <a:r>
+              <a:rPr lang="en-US" sz="2700" b="1" dirty="0" spc="-11" kern="0">
+                <a:solidFill>
+                  <a:srgbClr val="FF6A4D"/>
+                </a:solidFill>
+                <a:latin typeface="Be Vietnam Pro" pitchFamily="34" charset="0"/>
+                <a:ea typeface="Be Vietnam Pro" pitchFamily="34" charset="-122"/>
+                <a:cs typeface="Be Vietnam Pro" pitchFamily="34" charset="-120"/>
+              </a:rPr>
+              <a:t> với</a:t>
+            </a:r>
+            <a:r>
+              <a:rPr lang="en-US" sz="2700" b="1" dirty="0" spc="-4" kern="0">
+                <a:solidFill>
+                  <a:srgbClr val="FF6A4D"/>
+                </a:solidFill>
+                <a:latin typeface="Be Vietnam Pro" pitchFamily="34" charset="0"/>
+                <a:ea typeface="Be Vietnam Pro" pitchFamily="34" charset="-122"/>
+                <a:cs typeface="Be Vietnam Pro" pitchFamily="34" charset="-120"/>
+              </a:rPr>
+              <a:t> nội</a:t>
+            </a:r>
+            <a:r>
+              <a:rPr lang="en-US" sz="2700" b="1" dirty="0" spc="-2" kern="0">
+                <a:solidFill>
+                  <a:srgbClr val="FF6A4D"/>
+                </a:solidFill>
+                <a:latin typeface="Be Vietnam Pro" pitchFamily="34" charset="0"/>
+                <a:ea typeface="Be Vietnam Pro" pitchFamily="34" charset="-122"/>
+                <a:cs typeface="Be Vietnam Pro" pitchFamily="34" charset="-120"/>
+              </a:rPr>
+              <a:t> dung tin</a:t>
+            </a:r>
+            <a:r>
+              <a:rPr lang="en-US" sz="2700" b="1" dirty="0" spc="7" kern="0">
+                <a:solidFill>
+                  <a:srgbClr val="FF6A4D"/>
+                </a:solidFill>
+                <a:latin typeface="Be Vietnam Pro" pitchFamily="34" charset="0"/>
+                <a:ea typeface="Be Vietnam Pro" pitchFamily="34" charset="-122"/>
+                <a:cs typeface="Be Vietnam Pro" pitchFamily="34" charset="-120"/>
+              </a:rPr>
+              <a:t> trước</a:t>
+            </a:r>
+            <a:r>
+              <a:rPr lang="en-US" sz="2700" b="1" dirty="0" spc="11" kern="0">
+                <a:solidFill>
+                  <a:srgbClr val="FF6A4D"/>
+                </a:solidFill>
+                <a:latin typeface="Be Vietnam Pro" pitchFamily="34" charset="0"/>
+                <a:ea typeface="Be Vietnam Pro" pitchFamily="34" charset="-122"/>
+                <a:cs typeface="Be Vietnam Pro" pitchFamily="34" charset="-120"/>
+              </a:rPr>
+              <a:t> người</a:t>
+            </a:r>
+            <a:r>
+              <a:rPr lang="en-US" sz="2700" b="1" dirty="0" spc="-4" kern="0">
+                <a:solidFill>
+                  <a:srgbClr val="FF6A4D"/>
+                </a:solidFill>
+                <a:latin typeface="Be Vietnam Pro" pitchFamily="34" charset="0"/>
+                <a:ea typeface="Be Vietnam Pro" pitchFamily="34" charset="-122"/>
+                <a:cs typeface="Be Vietnam Pro" pitchFamily="34" charset="-120"/>
+              </a:rPr>
+              <a:t> nghe</a:t>
+            </a:r>
+            <a:r>
+              <a:rPr lang="en-US" sz="2700" b="1" dirty="0" spc="-1" kern="0">
+                <a:solidFill>
+                  <a:srgbClr val="FF6A4D"/>
+                </a:solidFill>
+                <a:latin typeface="Be Vietnam Pro" pitchFamily="34" charset="0"/>
+                <a:ea typeface="Be Vietnam Pro" pitchFamily="34" charset="-122"/>
+                <a:cs typeface="Be Vietnam Pro" pitchFamily="34" charset="-120"/>
+              </a:rPr>
+              <a:t> ở</a:t>
+            </a:r>
+            <a:r>
+              <a:rPr lang="en-US" sz="2700" b="1" dirty="0" spc="3" kern="0">
+                <a:solidFill>
+                  <a:srgbClr val="FF6A4D"/>
+                </a:solidFill>
+                <a:latin typeface="Be Vietnam Pro" pitchFamily="34" charset="0"/>
+                <a:ea typeface="Be Vietnam Pro" pitchFamily="34" charset="-122"/>
+                <a:cs typeface="Be Vietnam Pro" pitchFamily="34" charset="-120"/>
+              </a:rPr>
+              <a:t> đoạn</a:t>
+            </a:r>
+            <a:r>
+              <a:rPr lang="en-US" sz="2700" b="1" dirty="0" spc="7" kern="0">
+                <a:solidFill>
+                  <a:srgbClr val="FF6A4D"/>
+                </a:solidFill>
+                <a:latin typeface="Be Vietnam Pro" pitchFamily="34" charset="0"/>
+                <a:ea typeface="Be Vietnam Pro" pitchFamily="34" charset="-122"/>
+                <a:cs typeface="Be Vietnam Pro" pitchFamily="34" charset="-120"/>
+              </a:rPr>
+              <a:t> đầu.</a:t>
+            </a:r>
+            <a:endParaRPr lang="en-US" sz="2700" dirty="0"/>
+          </a:p>
+        </p:txBody>
+      </p:sp>
+      <p:sp>
+        <p:nvSpPr>
+          <p:cNvPr id="22" name="Text 20"/>
+          <p:cNvSpPr/>
+          <p:nvPr/>
+        </p:nvSpPr>
+        <p:spPr>
+          <a:xfrm>
+            <a:off x="1238250" y="8439150"/>
+            <a:ext cx="15811500" cy="628650"/>
+          </a:xfrm>
+          <a:prstGeom prst="rect">
+            <a:avLst/>
+          </a:prstGeom>
+          <a:noFill/>
+          <a:ln/>
+        </p:spPr>
+        <p:txBody>
+          <a:bodyPr wrap="square" lIns="0" tIns="11335" rIns="0" bIns="-11335" rtlCol="0" anchor="t"/>
+          <a:lstStyle/>
+          <a:p>
+            <a:pPr algn="l" indent="0" marL="0">
+              <a:lnSpc>
+                <a:spcPts val="2730"/>
+              </a:lnSpc>
+              <a:buNone/>
+            </a:pPr>
+            <a:r>
+              <a:rPr lang="en-US" sz="2100" dirty="0" spc="0" kern="0">
+                <a:solidFill>
+                  <a:srgbClr val="D8D3C4"/>
+                </a:solidFill>
+                <a:latin typeface="Be Vietnam Pro" pitchFamily="34" charset="0"/>
+                <a:ea typeface="Be Vietnam Pro" pitchFamily="34" charset="-122"/>
+                <a:cs typeface="Be Vietnam Pro" pitchFamily="34" charset="-120"/>
+              </a:rPr>
+              <a:t>Không</a:t>
+            </a:r>
+            <a:r>
+              <a:rPr lang="en-US" sz="2100" dirty="0" spc="1" kern="0">
+                <a:solidFill>
+                  <a:srgbClr val="D8D3C4"/>
+                </a:solidFill>
+                <a:latin typeface="Be Vietnam Pro" pitchFamily="34" charset="0"/>
+                <a:ea typeface="Be Vietnam Pro" pitchFamily="34" charset="-122"/>
+                <a:cs typeface="Be Vietnam Pro" pitchFamily="34" charset="-120"/>
+              </a:rPr>
+              <a:t> đúng</a:t>
+            </a:r>
+            <a:r>
+              <a:rPr lang="en-US" sz="2100" dirty="0" spc="-13" kern="0">
+                <a:solidFill>
+                  <a:srgbClr val="D8D3C4"/>
+                </a:solidFill>
+                <a:latin typeface="Be Vietnam Pro" pitchFamily="34" charset="0"/>
+                <a:ea typeface="Be Vietnam Pro" pitchFamily="34" charset="-122"/>
+                <a:cs typeface="Be Vietnam Pro" pitchFamily="34" charset="-120"/>
+              </a:rPr>
+              <a:t> với</a:t>
+            </a:r>
+            <a:r>
+              <a:rPr lang="en-US" sz="2100" dirty="0" spc="21" kern="0">
+                <a:solidFill>
+                  <a:srgbClr val="D8D3C4"/>
+                </a:solidFill>
+                <a:latin typeface="Be Vietnam Pro" pitchFamily="34" charset="0"/>
+                <a:ea typeface="Be Vietnam Pro" pitchFamily="34" charset="-122"/>
+                <a:cs typeface="Be Vietnam Pro" pitchFamily="34" charset="-120"/>
+              </a:rPr>
+              <a:t> địa</a:t>
+            </a:r>
+            <a:r>
+              <a:rPr lang="en-US" sz="2100" dirty="0" spc="0" kern="0">
+                <a:solidFill>
+                  <a:srgbClr val="D8D3C4"/>
+                </a:solidFill>
+                <a:latin typeface="Be Vietnam Pro" pitchFamily="34" charset="0"/>
+                <a:ea typeface="Be Vietnam Pro" pitchFamily="34" charset="-122"/>
+                <a:cs typeface="Be Vietnam Pro" pitchFamily="34" charset="-120"/>
+              </a:rPr>
+              <a:t> chỉ</a:t>
+            </a:r>
+            <a:r>
+              <a:rPr lang="en-US" sz="2100" dirty="0" spc="-1" kern="0">
+                <a:solidFill>
+                  <a:srgbClr val="D8D3C4"/>
+                </a:solidFill>
+                <a:latin typeface="Be Vietnam Pro" pitchFamily="34" charset="0"/>
+                <a:ea typeface="Be Vietnam Pro" pitchFamily="34" charset="-122"/>
+                <a:cs typeface="Be Vietnam Pro" pitchFamily="34" charset="-120"/>
+              </a:rPr>
+              <a:t> của</a:t>
+            </a:r>
+            <a:r>
+              <a:rPr lang="en-US" sz="2100" dirty="0" spc="-5" kern="0">
+                <a:solidFill>
+                  <a:srgbClr val="D8D3C4"/>
+                </a:solidFill>
+                <a:latin typeface="Be Vietnam Pro" pitchFamily="34" charset="0"/>
+                <a:ea typeface="Be Vietnam Pro" pitchFamily="34" charset="-122"/>
+                <a:cs typeface="Be Vietnam Pro" pitchFamily="34" charset="-120"/>
+              </a:rPr>
+              <a:t> bạn</a:t>
+            </a:r>
+            <a:r>
+              <a:rPr lang="en-US" sz="2100" dirty="0" spc="2" kern="0">
+                <a:solidFill>
+                  <a:srgbClr val="D8D3C4"/>
+                </a:solidFill>
+                <a:latin typeface="Be Vietnam Pro" pitchFamily="34" charset="0"/>
+                <a:ea typeface="Be Vietnam Pro" pitchFamily="34" charset="-122"/>
+                <a:cs typeface="Be Vietnam Pro" pitchFamily="34" charset="-120"/>
+              </a:rPr>
+              <a:t> trước</a:t>
+            </a:r>
+            <a:r>
+              <a:rPr lang="en-US" sz="2100" dirty="0" spc="5" kern="0">
+                <a:solidFill>
+                  <a:srgbClr val="D8D3C4"/>
+                </a:solidFill>
+                <a:latin typeface="Be Vietnam Pro" pitchFamily="34" charset="0"/>
+                <a:ea typeface="Be Vietnam Pro" pitchFamily="34" charset="-122"/>
+                <a:cs typeface="Be Vietnam Pro" pitchFamily="34" charset="-120"/>
+              </a:rPr>
+              <a:t> người</a:t>
+            </a:r>
+            <a:r>
+              <a:rPr lang="en-US" sz="2100" dirty="0" spc="-1" kern="0">
+                <a:solidFill>
+                  <a:srgbClr val="D8D3C4"/>
+                </a:solidFill>
+                <a:latin typeface="Be Vietnam Pro" pitchFamily="34" charset="0"/>
+                <a:ea typeface="Be Vietnam Pro" pitchFamily="34" charset="-122"/>
+                <a:cs typeface="Be Vietnam Pro" pitchFamily="34" charset="-120"/>
+              </a:rPr>
+              <a:t> nghe</a:t>
+            </a:r>
+            <a:r>
+              <a:rPr lang="en-US" sz="2100" dirty="0" spc="8" kern="0">
+                <a:solidFill>
+                  <a:srgbClr val="D8D3C4"/>
+                </a:solidFill>
+                <a:latin typeface="Be Vietnam Pro" pitchFamily="34" charset="0"/>
+                <a:ea typeface="Be Vietnam Pro" pitchFamily="34" charset="-122"/>
+                <a:cs typeface="Be Vietnam Pro" pitchFamily="34" charset="-120"/>
+              </a:rPr>
+              <a:t> đó,</a:t>
+            </a:r>
+            <a:r>
+              <a:rPr lang="en-US" sz="2100" dirty="0" spc="-13" kern="0">
+                <a:solidFill>
+                  <a:srgbClr val="D8D3C4"/>
+                </a:solidFill>
+                <a:latin typeface="Be Vietnam Pro" pitchFamily="34" charset="0"/>
+                <a:ea typeface="Be Vietnam Pro" pitchFamily="34" charset="-122"/>
+                <a:cs typeface="Be Vietnam Pro" pitchFamily="34" charset="-120"/>
+              </a:rPr>
+              <a:t> với</a:t>
+            </a:r>
+            <a:r>
+              <a:rPr lang="en-US" sz="2100" dirty="0" spc="-10" kern="0">
+                <a:solidFill>
+                  <a:srgbClr val="D8D3C4"/>
+                </a:solidFill>
+                <a:latin typeface="Be Vietnam Pro" pitchFamily="34" charset="0"/>
+                <a:ea typeface="Be Vietnam Pro" pitchFamily="34" charset="-122"/>
+                <a:cs typeface="Be Vietnam Pro" pitchFamily="34" charset="-120"/>
+              </a:rPr>
+              <a:t> máy</a:t>
+            </a:r>
+            <a:r>
+              <a:rPr lang="en-US" sz="2100" dirty="0" spc="0" kern="0">
+                <a:solidFill>
+                  <a:srgbClr val="D8D3C4"/>
+                </a:solidFill>
+                <a:latin typeface="Be Vietnam Pro" pitchFamily="34" charset="0"/>
+                <a:ea typeface="Be Vietnam Pro" pitchFamily="34" charset="-122"/>
+                <a:cs typeface="Be Vietnam Pro" pitchFamily="34" charset="-120"/>
+              </a:rPr>
+              <a:t> chủ</a:t>
+            </a:r>
+            <a:r>
+              <a:rPr lang="en-US" sz="2100" dirty="0" spc="-2" kern="0">
+                <a:solidFill>
+                  <a:srgbClr val="D8D3C4"/>
+                </a:solidFill>
+                <a:latin typeface="Be Vietnam Pro" pitchFamily="34" charset="0"/>
+                <a:ea typeface="Be Vietnam Pro" pitchFamily="34" charset="-122"/>
+                <a:cs typeface="Be Vietnam Pro" pitchFamily="34" charset="-120"/>
+              </a:rPr>
+              <a:t> VPN,</a:t>
+            </a:r>
+            <a:r>
+              <a:rPr lang="en-US" sz="2100" dirty="0" spc="-10" kern="0">
+                <a:solidFill>
+                  <a:srgbClr val="D8D3C4"/>
+                </a:solidFill>
+                <a:latin typeface="Be Vietnam Pro" pitchFamily="34" charset="0"/>
+                <a:ea typeface="Be Vietnam Pro" pitchFamily="34" charset="-122"/>
+                <a:cs typeface="Be Vietnam Pro" pitchFamily="34" charset="-120"/>
+              </a:rPr>
+              <a:t> hay</a:t>
+            </a:r>
+            <a:r>
+              <a:rPr lang="en-US" sz="2100" dirty="0" spc="-13" kern="0">
+                <a:solidFill>
+                  <a:srgbClr val="D8D3C4"/>
+                </a:solidFill>
+                <a:latin typeface="Be Vietnam Pro" pitchFamily="34" charset="0"/>
+                <a:ea typeface="Be Vietnam Pro" pitchFamily="34" charset="-122"/>
+                <a:cs typeface="Be Vietnam Pro" pitchFamily="34" charset="-120"/>
+              </a:rPr>
+              <a:t> với</a:t>
+            </a:r>
+            <a:r>
+              <a:rPr lang="en-US" sz="2100" dirty="0" spc="-15" kern="0">
+                <a:solidFill>
+                  <a:srgbClr val="D8D3C4"/>
+                </a:solidFill>
+                <a:latin typeface="Be Vietnam Pro" pitchFamily="34" charset="0"/>
+                <a:ea typeface="Be Vietnam Pro" pitchFamily="34" charset="-122"/>
+                <a:cs typeface="Be Vietnam Pro" pitchFamily="34" charset="-120"/>
+              </a:rPr>
+              <a:t> trang</a:t>
+            </a:r>
+            <a:r>
+              <a:rPr lang="en-US" sz="2100" dirty="0" spc="-5" kern="0">
+                <a:solidFill>
+                  <a:srgbClr val="D8D3C4"/>
+                </a:solidFill>
+                <a:latin typeface="Be Vietnam Pro" pitchFamily="34" charset="0"/>
+                <a:ea typeface="Be Vietnam Pro" pitchFamily="34" charset="-122"/>
+                <a:cs typeface="Be Vietnam Pro" pitchFamily="34" charset="-120"/>
+              </a:rPr>
+              <a:t> bạn</a:t>
+            </a:r>
+            <a:r>
+              <a:rPr lang="en-US" sz="2100" dirty="0" spc="13" kern="0">
+                <a:solidFill>
+                  <a:srgbClr val="D8D3C4"/>
+                </a:solidFill>
+                <a:latin typeface="Be Vietnam Pro" pitchFamily="34" charset="0"/>
+                <a:ea typeface="Be Vietnam Pro" pitchFamily="34" charset="-122"/>
+                <a:cs typeface="Be Vietnam Pro" pitchFamily="34" charset="-120"/>
+              </a:rPr>
+              <a:t> đã</a:t>
+            </a:r>
+            <a:r>
+              <a:rPr lang="en-US" sz="2100" dirty="0" spc="8" kern="0">
+                <a:solidFill>
+                  <a:srgbClr val="D8D3C4"/>
+                </a:solidFill>
+                <a:latin typeface="Be Vietnam Pro" pitchFamily="34" charset="0"/>
+                <a:ea typeface="Be Vietnam Pro" pitchFamily="34" charset="-122"/>
+                <a:cs typeface="Be Vietnam Pro" pitchFamily="34" charset="-120"/>
+              </a:rPr>
+              <a:t> đăng</a:t>
+            </a:r>
+            <a:r>
+              <a:rPr lang="en-US" sz="2100" dirty="0" spc="-2" kern="0">
+                <a:solidFill>
+                  <a:srgbClr val="D8D3C4"/>
+                </a:solidFill>
+                <a:latin typeface="Be Vietnam Pro" pitchFamily="34" charset="0"/>
+                <a:ea typeface="Be Vietnam Pro" pitchFamily="34" charset="-122"/>
+                <a:cs typeface="Be Vietnam Pro" pitchFamily="34" charset="-120"/>
+              </a:rPr>
+              <a:t> nhập.</a:t>
+            </a:r>
+            <a:endParaRPr lang="en-US" sz="2100" dirty="0"/>
+          </a:p>
+        </p:txBody>
+      </p:sp>
+      <p:sp>
+        <p:nvSpPr>
+          <p:cNvPr id="23" name="Text 21"/>
+          <p:cNvSpPr/>
+          <p:nvPr/>
+        </p:nvSpPr>
+        <p:spPr>
+          <a:xfrm>
+            <a:off x="914400" y="9715500"/>
+            <a:ext cx="7620000" cy="285750"/>
           </a:xfrm>
           <a:prstGeom prst="rect">
             <a:avLst/>
@@ -21743,370 +22424,6 @@
               <a:buNone/>
             </a:pPr>
             <a:r>
-              <a:rPr lang="en-US" sz="3000" b="1" dirty="0" spc="-7" kern="0">
-                <a:solidFill>
-                  <a:srgbClr val="FF6A4D"/>
-                </a:solidFill>
-                <a:latin typeface="Be Vietnam Pro" pitchFamily="34" charset="0"/>
-                <a:ea typeface="Be Vietnam Pro" pitchFamily="34" charset="-122"/>
-                <a:cs typeface="Be Vietnam Pro" pitchFamily="34" charset="-120"/>
-              </a:rPr>
-              <a:t>“Riêng</a:t>
-            </a:r>
-            <a:r>
-              <a:rPr lang="en-US" sz="3000" b="1" dirty="0" spc="3" kern="0">
-                <a:solidFill>
-                  <a:srgbClr val="FF6A4D"/>
-                </a:solidFill>
-                <a:latin typeface="Be Vietnam Pro" pitchFamily="34" charset="0"/>
-                <a:ea typeface="Be Vietnam Pro" pitchFamily="34" charset="-122"/>
-                <a:cs typeface="Be Vietnam Pro" pitchFamily="34" charset="-120"/>
-              </a:rPr>
-              <a:t> tư”</a:t>
-            </a:r>
-            <a:r>
-              <a:rPr lang="en-US" sz="3000" b="1" dirty="0" spc="-27" kern="0">
-                <a:solidFill>
-                  <a:srgbClr val="FF6A4D"/>
-                </a:solidFill>
-                <a:latin typeface="Be Vietnam Pro" pitchFamily="34" charset="0"/>
-                <a:ea typeface="Be Vietnam Pro" pitchFamily="34" charset="-122"/>
-                <a:cs typeface="Be Vietnam Pro" pitchFamily="34" charset="-120"/>
-              </a:rPr>
-              <a:t> và</a:t>
-            </a:r>
-            <a:r>
-              <a:rPr lang="en-US" sz="3000" b="1" dirty="0" spc="0" kern="0">
-                <a:solidFill>
-                  <a:srgbClr val="FF6A4D"/>
-                </a:solidFill>
-                <a:latin typeface="Be Vietnam Pro" pitchFamily="34" charset="0"/>
-                <a:ea typeface="Be Vietnam Pro" pitchFamily="34" charset="-122"/>
-                <a:cs typeface="Be Vietnam Pro" pitchFamily="34" charset="-120"/>
-              </a:rPr>
-              <a:t> “ẩn</a:t>
-            </a:r>
-            <a:r>
-              <a:rPr lang="en-US" sz="3000" b="1" dirty="0" spc="-1" kern="0">
-                <a:solidFill>
-                  <a:srgbClr val="FF6A4D"/>
-                </a:solidFill>
-                <a:latin typeface="Be Vietnam Pro" pitchFamily="34" charset="0"/>
-                <a:ea typeface="Be Vietnam Pro" pitchFamily="34" charset="-122"/>
-                <a:cs typeface="Be Vietnam Pro" pitchFamily="34" charset="-120"/>
-              </a:rPr>
-              <a:t> danh”</a:t>
-            </a:r>
-            <a:r>
-              <a:rPr lang="en-US" sz="3000" b="1" dirty="0" spc="2" kern="0">
-                <a:solidFill>
-                  <a:srgbClr val="FF6A4D"/>
-                </a:solidFill>
-                <a:latin typeface="Be Vietnam Pro" pitchFamily="34" charset="0"/>
-                <a:ea typeface="Be Vietnam Pro" pitchFamily="34" charset="-122"/>
-                <a:cs typeface="Be Vietnam Pro" pitchFamily="34" charset="-120"/>
-              </a:rPr>
-              <a:t> chỉ</a:t>
-            </a:r>
-            <a:r>
-              <a:rPr lang="en-US" sz="3000" b="1" dirty="0" spc="-3" kern="0">
-                <a:solidFill>
-                  <a:srgbClr val="FF6A4D"/>
-                </a:solidFill>
-                <a:latin typeface="Be Vietnam Pro" pitchFamily="34" charset="0"/>
-                <a:ea typeface="Be Vietnam Pro" pitchFamily="34" charset="-122"/>
-                <a:cs typeface="Be Vietnam Pro" pitchFamily="34" charset="-120"/>
-              </a:rPr>
-              <a:t> đúng</a:t>
-            </a:r>
-            <a:r>
-              <a:rPr lang="en-US" sz="3000" b="1" dirty="0" spc="-13" kern="0">
-                <a:solidFill>
-                  <a:srgbClr val="FF6A4D"/>
-                </a:solidFill>
-                <a:latin typeface="Be Vietnam Pro" pitchFamily="34" charset="0"/>
-                <a:ea typeface="Be Vietnam Pro" pitchFamily="34" charset="-122"/>
-                <a:cs typeface="Be Vietnam Pro" pitchFamily="34" charset="-120"/>
-              </a:rPr>
-              <a:t> với</a:t>
-            </a:r>
-            <a:r>
-              <a:rPr lang="en-US" sz="3000" b="1" dirty="0" spc="12" kern="0">
-                <a:solidFill>
-                  <a:srgbClr val="FF6A4D"/>
-                </a:solidFill>
-                <a:latin typeface="Be Vietnam Pro" pitchFamily="34" charset="0"/>
-                <a:ea typeface="Be Vietnam Pro" pitchFamily="34" charset="-122"/>
-                <a:cs typeface="Be Vietnam Pro" pitchFamily="34" charset="-120"/>
-              </a:rPr>
-              <a:t> người</a:t>
-            </a:r>
-            <a:r>
-              <a:rPr lang="en-US" sz="3000" b="1" dirty="0" spc="-7" kern="0">
-                <a:solidFill>
-                  <a:srgbClr val="FF6A4D"/>
-                </a:solidFill>
-                <a:latin typeface="Be Vietnam Pro" pitchFamily="34" charset="0"/>
-                <a:ea typeface="Be Vietnam Pro" pitchFamily="34" charset="-122"/>
-                <a:cs typeface="Be Vietnam Pro" pitchFamily="34" charset="-120"/>
-              </a:rPr>
-              <a:t> nghe</a:t>
-            </a:r>
-            <a:r>
-              <a:rPr lang="en-US" sz="3000" b="1" dirty="0" spc="0" kern="0">
-                <a:solidFill>
-                  <a:srgbClr val="FF6A4D"/>
-                </a:solidFill>
-                <a:latin typeface="Be Vietnam Pro" pitchFamily="34" charset="0"/>
-                <a:ea typeface="Be Vietnam Pro" pitchFamily="34" charset="-122"/>
-                <a:cs typeface="Be Vietnam Pro" pitchFamily="34" charset="-120"/>
-              </a:rPr>
-              <a:t> ở</a:t>
-            </a:r>
-            <a:r>
-              <a:rPr lang="en-US" sz="3000" b="1" dirty="0" spc="3" kern="0">
-                <a:solidFill>
-                  <a:srgbClr val="FF6A4D"/>
-                </a:solidFill>
-                <a:latin typeface="Be Vietnam Pro" pitchFamily="34" charset="0"/>
-                <a:ea typeface="Be Vietnam Pro" pitchFamily="34" charset="-122"/>
-                <a:cs typeface="Be Vietnam Pro" pitchFamily="34" charset="-120"/>
-              </a:rPr>
-              <a:t> đoạn</a:t>
-            </a:r>
-            <a:r>
-              <a:rPr lang="en-US" sz="3000" b="1" dirty="0" spc="11" kern="0">
-                <a:solidFill>
-                  <a:srgbClr val="FF6A4D"/>
-                </a:solidFill>
-                <a:latin typeface="Be Vietnam Pro" pitchFamily="34" charset="0"/>
-                <a:ea typeface="Be Vietnam Pro" pitchFamily="34" charset="-122"/>
-                <a:cs typeface="Be Vietnam Pro" pitchFamily="34" charset="-120"/>
-              </a:rPr>
-              <a:t> đầu.</a:t>
-            </a:r>
-            <a:endParaRPr lang="en-US" sz="3000" dirty="0"/>
-          </a:p>
-        </p:txBody>
-      </p:sp>
-      <p:sp>
-        <p:nvSpPr>
-          <p:cNvPr id="22" name="Text 20"/>
-          <p:cNvSpPr/>
-          <p:nvPr/>
-        </p:nvSpPr>
-        <p:spPr>
-          <a:xfrm>
-            <a:off x="1238250" y="8439150"/>
-            <a:ext cx="15811500" cy="419100"/>
-          </a:xfrm>
-          <a:prstGeom prst="rect">
-            <a:avLst/>
-          </a:prstGeom>
-          <a:noFill/>
-          <a:ln/>
-        </p:spPr>
-        <p:txBody>
-          <a:bodyPr wrap="square" lIns="0" tIns="0" rIns="0" bIns="0" rtlCol="0" anchor="t"/>
-          <a:lstStyle/>
-          <a:p>
-            <a:pPr algn="l" indent="0" marL="0">
-              <a:buNone/>
-            </a:pPr>
-            <a:r>
-              <a:rPr lang="en-US" sz="2250" dirty="0" spc="1" kern="0">
-                <a:solidFill>
-                  <a:srgbClr val="D8D3C4"/>
-                </a:solidFill>
-                <a:latin typeface="Be Vietnam Pro" pitchFamily="34" charset="0"/>
-                <a:ea typeface="Be Vietnam Pro" pitchFamily="34" charset="-122"/>
-                <a:cs typeface="Be Vietnam Pro" pitchFamily="34" charset="-120"/>
-              </a:rPr>
-              <a:t>Không</a:t>
-            </a:r>
-            <a:r>
-              <a:rPr lang="en-US" sz="2250" dirty="0" spc="2" kern="0">
-                <a:solidFill>
-                  <a:srgbClr val="D8D3C4"/>
-                </a:solidFill>
-                <a:latin typeface="Be Vietnam Pro" pitchFamily="34" charset="0"/>
-                <a:ea typeface="Be Vietnam Pro" pitchFamily="34" charset="-122"/>
-                <a:cs typeface="Be Vietnam Pro" pitchFamily="34" charset="-120"/>
-              </a:rPr>
-              <a:t> đúng</a:t>
-            </a:r>
-            <a:r>
-              <a:rPr lang="en-US" sz="2250" dirty="0" spc="-11" kern="0">
-                <a:solidFill>
-                  <a:srgbClr val="D8D3C4"/>
-                </a:solidFill>
-                <a:latin typeface="Be Vietnam Pro" pitchFamily="34" charset="0"/>
-                <a:ea typeface="Be Vietnam Pro" pitchFamily="34" charset="-122"/>
-                <a:cs typeface="Be Vietnam Pro" pitchFamily="34" charset="-120"/>
-              </a:rPr>
-              <a:t> với</a:t>
-            </a:r>
-            <a:r>
-              <a:rPr lang="en-US" sz="2250" dirty="0" spc="-10" kern="0">
-                <a:solidFill>
-                  <a:srgbClr val="D8D3C4"/>
-                </a:solidFill>
-                <a:latin typeface="Be Vietnam Pro" pitchFamily="34" charset="0"/>
-                <a:ea typeface="Be Vietnam Pro" pitchFamily="34" charset="-122"/>
-                <a:cs typeface="Be Vietnam Pro" pitchFamily="34" charset="-120"/>
-              </a:rPr>
-              <a:t> máy</a:t>
-            </a:r>
-            <a:r>
-              <a:rPr lang="en-US" sz="2250" dirty="0" spc="3" kern="0">
-                <a:solidFill>
-                  <a:srgbClr val="D8D3C4"/>
-                </a:solidFill>
-                <a:latin typeface="Be Vietnam Pro" pitchFamily="34" charset="0"/>
-                <a:ea typeface="Be Vietnam Pro" pitchFamily="34" charset="-122"/>
-                <a:cs typeface="Be Vietnam Pro" pitchFamily="34" charset="-120"/>
-              </a:rPr>
-              <a:t> chủ</a:t>
-            </a:r>
-            <a:r>
-              <a:rPr lang="en-US" sz="2250" dirty="0" spc="0" kern="0">
-                <a:solidFill>
-                  <a:srgbClr val="D8D3C4"/>
-                </a:solidFill>
-                <a:latin typeface="Be Vietnam Pro" pitchFamily="34" charset="0"/>
-                <a:ea typeface="Be Vietnam Pro" pitchFamily="34" charset="-122"/>
-                <a:cs typeface="Be Vietnam Pro" pitchFamily="34" charset="-120"/>
-              </a:rPr>
-              <a:t> VPN,</a:t>
-            </a:r>
-            <a:r>
-              <a:rPr lang="en-US" sz="2250" dirty="0" spc="-17" kern="0">
-                <a:solidFill>
-                  <a:srgbClr val="D8D3C4"/>
-                </a:solidFill>
-                <a:latin typeface="Be Vietnam Pro" pitchFamily="34" charset="0"/>
-                <a:ea typeface="Be Vietnam Pro" pitchFamily="34" charset="-122"/>
-                <a:cs typeface="Be Vietnam Pro" pitchFamily="34" charset="-120"/>
-              </a:rPr>
-              <a:t> và</a:t>
-            </a:r>
-            <a:r>
-              <a:rPr lang="en-US" sz="2250" dirty="0" spc="1" kern="0">
-                <a:solidFill>
-                  <a:srgbClr val="D8D3C4"/>
-                </a:solidFill>
-                <a:latin typeface="Be Vietnam Pro" pitchFamily="34" charset="0"/>
-                <a:ea typeface="Be Vietnam Pro" pitchFamily="34" charset="-122"/>
-                <a:cs typeface="Be Vietnam Pro" pitchFamily="34" charset="-120"/>
-              </a:rPr>
-              <a:t> không</a:t>
-            </a:r>
-            <a:r>
-              <a:rPr lang="en-US" sz="2250" dirty="0" spc="2" kern="0">
-                <a:solidFill>
-                  <a:srgbClr val="D8D3C4"/>
-                </a:solidFill>
-                <a:latin typeface="Be Vietnam Pro" pitchFamily="34" charset="0"/>
-                <a:ea typeface="Be Vietnam Pro" pitchFamily="34" charset="-122"/>
-                <a:cs typeface="Be Vietnam Pro" pitchFamily="34" charset="-120"/>
-              </a:rPr>
-              <a:t> đúng</a:t>
-            </a:r>
-            <a:r>
-              <a:rPr lang="en-US" sz="2250" dirty="0" spc="-12" kern="0">
-                <a:solidFill>
-                  <a:srgbClr val="D8D3C4"/>
-                </a:solidFill>
-                <a:latin typeface="Be Vietnam Pro" pitchFamily="34" charset="0"/>
-                <a:ea typeface="Be Vietnam Pro" pitchFamily="34" charset="-122"/>
-                <a:cs typeface="Be Vietnam Pro" pitchFamily="34" charset="-120"/>
-              </a:rPr>
-              <a:t> với</a:t>
-            </a:r>
-            <a:r>
-              <a:rPr lang="en-US" sz="2250" dirty="0" spc="-16" kern="0">
-                <a:solidFill>
-                  <a:srgbClr val="D8D3C4"/>
-                </a:solidFill>
-                <a:latin typeface="Be Vietnam Pro" pitchFamily="34" charset="0"/>
-                <a:ea typeface="Be Vietnam Pro" pitchFamily="34" charset="-122"/>
-                <a:cs typeface="Be Vietnam Pro" pitchFamily="34" charset="-120"/>
-              </a:rPr>
-              <a:t> trang</a:t>
-            </a:r>
-            <a:r>
-              <a:rPr lang="en-US" sz="2250" dirty="0" spc="-1" kern="0">
-                <a:solidFill>
-                  <a:srgbClr val="D8D3C4"/>
-                </a:solidFill>
-                <a:latin typeface="Be Vietnam Pro" pitchFamily="34" charset="0"/>
-                <a:ea typeface="Be Vietnam Pro" pitchFamily="34" charset="-122"/>
-                <a:cs typeface="Be Vietnam Pro" pitchFamily="34" charset="-120"/>
-              </a:rPr>
-              <a:t> bạn</a:t>
-            </a:r>
-            <a:r>
-              <a:rPr lang="en-US" sz="2250" dirty="0" spc="15" kern="0">
-                <a:solidFill>
-                  <a:srgbClr val="D8D3C4"/>
-                </a:solidFill>
-                <a:latin typeface="Be Vietnam Pro" pitchFamily="34" charset="0"/>
-                <a:ea typeface="Be Vietnam Pro" pitchFamily="34" charset="-122"/>
-                <a:cs typeface="Be Vietnam Pro" pitchFamily="34" charset="-120"/>
-              </a:rPr>
-              <a:t> đã</a:t>
-            </a:r>
-            <a:r>
-              <a:rPr lang="en-US" sz="2250" dirty="0" spc="9" kern="0">
-                <a:solidFill>
-                  <a:srgbClr val="D8D3C4"/>
-                </a:solidFill>
-                <a:latin typeface="Be Vietnam Pro" pitchFamily="34" charset="0"/>
-                <a:ea typeface="Be Vietnam Pro" pitchFamily="34" charset="-122"/>
-                <a:cs typeface="Be Vietnam Pro" pitchFamily="34" charset="-120"/>
-              </a:rPr>
-              <a:t> đăng</a:t>
-            </a:r>
-            <a:r>
-              <a:rPr lang="en-US" sz="2250" dirty="0" spc="2" kern="0">
-                <a:solidFill>
-                  <a:srgbClr val="D8D3C4"/>
-                </a:solidFill>
-                <a:latin typeface="Be Vietnam Pro" pitchFamily="34" charset="0"/>
-                <a:ea typeface="Be Vietnam Pro" pitchFamily="34" charset="-122"/>
-                <a:cs typeface="Be Vietnam Pro" pitchFamily="34" charset="-120"/>
-              </a:rPr>
-              <a:t> nhập.</a:t>
-            </a:r>
-            <a:endParaRPr lang="en-US" sz="2250" dirty="0"/>
-          </a:p>
-        </p:txBody>
-      </p:sp>
-      <p:sp>
-        <p:nvSpPr>
-          <p:cNvPr id="23" name="Text 21"/>
-          <p:cNvSpPr/>
-          <p:nvPr/>
-        </p:nvSpPr>
-        <p:spPr>
-          <a:xfrm>
-            <a:off x="914400" y="9715500"/>
-            <a:ext cx="7620000" cy="285750"/>
-          </a:xfrm>
-          <a:prstGeom prst="rect">
-            <a:avLst/>
-          </a:prstGeom>
-          <a:noFill/>
-          <a:ln/>
-        </p:spPr>
-        <p:txBody>
-          <a:bodyPr wrap="square" lIns="0" tIns="0" rIns="0" bIns="0" rtlCol="0" anchor="t"/>
-          <a:lstStyle/>
-          <a:p>
-            <a:pPr algn="l" indent="0" marL="0">
-              <a:buNone/>
-            </a:pPr>
-            <a:r>
               <a:rPr lang="en-US" sz="1650" dirty="0" spc="-12" kern="0">
                 <a:solidFill>
                   <a:srgbClr val="9A98A0"/>
@@ -22200,7 +22517,7 @@
       </p:sp>
       <p:sp>
         <p:nvSpPr>
-          <p:cNvPr id="24" name="Connector line-1792383331696-803171954"/>
+          <p:cNvPr id="24" name="Connector line-1792405069930-212940757"/>
           <p:cNvSpPr/>
           <p:nvPr/>
         </p:nvSpPr>
@@ -25262,7 +25579,7 @@
       </p:sp>
       <p:sp>
         <p:nvSpPr>
-          <p:cNvPr id="4" name="Connector line-1792383535546-605106503"/>
+          <p:cNvPr id="4" name="Connector line-1792405109600-633964343"/>
           <p:cNvSpPr/>
           <p:nvPr/>
         </p:nvSpPr>
@@ -25287,7 +25604,7 @@
       </p:sp>
       <p:sp>
         <p:nvSpPr>
-          <p:cNvPr id="5" name="Connector line-1792383535546-52439448"/>
+          <p:cNvPr id="5" name="Connector line-1792405109601-969301389"/>
           <p:cNvSpPr/>
           <p:nvPr/>
         </p:nvSpPr>
@@ -25312,7 +25629,7 @@
       </p:sp>
       <p:sp>
         <p:nvSpPr>
-          <p:cNvPr id="6" name="Connector line-1792383535547-507049213"/>
+          <p:cNvPr id="6" name="Connector line-1792405109601-219945357"/>
           <p:cNvSpPr/>
           <p:nvPr/>
         </p:nvSpPr>
@@ -25892,7 +26209,7 @@
         </p:nvSpPr>
         <p:spPr>
           <a:xfrm>
-            <a:off x="9525000" y="3028950"/>
+            <a:off x="9525000" y="2990850"/>
             <a:ext cx="7429500" cy="266700"/>
           </a:xfrm>
           <a:prstGeom prst="rect">
@@ -25953,174 +26270,8 @@
         </p:nvSpPr>
         <p:spPr>
           <a:xfrm>
-            <a:off x="9525000" y="3352800"/>
-            <a:ext cx="7524750" cy="457200"/>
-          </a:xfrm>
-          <a:prstGeom prst="rect">
-            <a:avLst/>
-          </a:prstGeom>
-          <a:noFill/>
-          <a:ln/>
-        </p:spPr>
-        <p:txBody>
-          <a:bodyPr wrap="square" lIns="0" tIns="0" rIns="0" bIns="0" rtlCol="0" anchor="t"/>
-          <a:lstStyle/>
-          <a:p>
-            <a:pPr algn="l" indent="0" marL="0">
-              <a:buNone/>
-            </a:pPr>
-            <a:r>
-              <a:rPr lang="en-US" sz="2550" b="1" dirty="0" spc="-1" kern="0">
-                <a:solidFill>
-                  <a:srgbClr val="FFFFFF"/>
-                </a:solidFill>
-                <a:latin typeface="Be Vietnam Pro" pitchFamily="34" charset="0"/>
-                <a:ea typeface="Be Vietnam Pro" pitchFamily="34" charset="-122"/>
-                <a:cs typeface="Be Vietnam Pro" pitchFamily="34" charset="-120"/>
-              </a:rPr>
-              <a:t>Chỉ</a:t>
-            </a:r>
-            <a:r>
-              <a:rPr lang="en-US" sz="2550" b="1" dirty="0" spc="-8" kern="0">
-                <a:solidFill>
-                  <a:srgbClr val="FFFFFF"/>
-                </a:solidFill>
-                <a:latin typeface="Be Vietnam Pro" pitchFamily="34" charset="0"/>
-                <a:ea typeface="Be Vietnam Pro" pitchFamily="34" charset="-122"/>
-                <a:cs typeface="Be Vietnam Pro" pitchFamily="34" charset="-120"/>
-              </a:rPr>
-              <a:t> thấy</a:t>
-            </a:r>
-            <a:r>
-              <a:rPr lang="en-US" sz="2550" b="1" dirty="0" spc="-30" kern="0">
-                <a:solidFill>
-                  <a:srgbClr val="FFFFFF"/>
-                </a:solidFill>
-                <a:latin typeface="Be Vietnam Pro" pitchFamily="34" charset="0"/>
-                <a:ea typeface="Be Vietnam Pro" pitchFamily="34" charset="-122"/>
-                <a:cs typeface="Be Vietnam Pro" pitchFamily="34" charset="-120"/>
-              </a:rPr>
-              <a:t> kết</a:t>
-            </a:r>
-            <a:r>
-              <a:rPr lang="en-US" sz="2550" b="1" dirty="0" spc="-3" kern="0">
-                <a:solidFill>
-                  <a:srgbClr val="FFFFFF"/>
-                </a:solidFill>
-                <a:latin typeface="Be Vietnam Pro" pitchFamily="34" charset="0"/>
-                <a:ea typeface="Be Vietnam Pro" pitchFamily="34" charset="-122"/>
-                <a:cs typeface="Be Vietnam Pro" pitchFamily="34" charset="-120"/>
-              </a:rPr>
-              <a:t> nối,</a:t>
-            </a:r>
-            <a:r>
-              <a:rPr lang="en-US" sz="2550" b="1" dirty="0" spc="0" kern="0">
-                <a:solidFill>
-                  <a:srgbClr val="FFFFFF"/>
-                </a:solidFill>
-                <a:latin typeface="Be Vietnam Pro" pitchFamily="34" charset="0"/>
-                <a:ea typeface="Be Vietnam Pro" pitchFamily="34" charset="-122"/>
-                <a:cs typeface="Be Vietnam Pro" pitchFamily="34" charset="-120"/>
-              </a:rPr>
-              <a:t> kích</a:t>
-            </a:r>
-            <a:r>
-              <a:rPr lang="en-US" sz="2550" b="1" dirty="0" spc="8" kern="0">
-                <a:solidFill>
-                  <a:srgbClr val="FFFFFF"/>
-                </a:solidFill>
-                <a:latin typeface="Be Vietnam Pro" pitchFamily="34" charset="0"/>
-                <a:ea typeface="Be Vietnam Pro" pitchFamily="34" charset="-122"/>
-                <a:cs typeface="Be Vietnam Pro" pitchFamily="34" charset="-120"/>
-              </a:rPr>
-              <a:t> thước,</a:t>
-            </a:r>
-            <a:r>
-              <a:rPr lang="en-US" sz="2550" b="1" dirty="0" spc="4" kern="0">
-                <a:solidFill>
-                  <a:srgbClr val="FFFFFF"/>
-                </a:solidFill>
-                <a:latin typeface="Be Vietnam Pro" pitchFamily="34" charset="0"/>
-                <a:ea typeface="Be Vietnam Pro" pitchFamily="34" charset="-122"/>
-                <a:cs typeface="Be Vietnam Pro" pitchFamily="34" charset="-120"/>
-              </a:rPr>
-              <a:t> thời</a:t>
-            </a:r>
-            <a:r>
-              <a:rPr lang="en-US" sz="2550" b="1" dirty="0" spc="11" kern="0">
-                <a:solidFill>
-                  <a:srgbClr val="FFFFFF"/>
-                </a:solidFill>
-                <a:latin typeface="Be Vietnam Pro" pitchFamily="34" charset="0"/>
-                <a:ea typeface="Be Vietnam Pro" pitchFamily="34" charset="-122"/>
-                <a:cs typeface="Be Vietnam Pro" pitchFamily="34" charset="-120"/>
-              </a:rPr>
-              <a:t> điểm</a:t>
-            </a:r>
-            <a:endParaRPr lang="en-US" sz="2550" dirty="0"/>
-          </a:p>
-        </p:txBody>
-      </p:sp>
-      <p:sp>
-        <p:nvSpPr>
-          <p:cNvPr id="23" name="Text 21"/>
-          <p:cNvSpPr/>
-          <p:nvPr/>
-        </p:nvSpPr>
-        <p:spPr>
-          <a:xfrm>
-            <a:off x="9525000" y="4152900"/>
-            <a:ext cx="7429500" cy="266700"/>
-          </a:xfrm>
-          <a:prstGeom prst="rect">
-            <a:avLst/>
-          </a:prstGeom>
-          <a:noFill/>
-          <a:ln/>
-        </p:spPr>
-        <p:txBody>
-          <a:bodyPr wrap="square" lIns="0" tIns="0" rIns="0" bIns="0" rtlCol="0" anchor="t"/>
-          <a:lstStyle/>
-          <a:p>
-            <a:pPr algn="l" indent="0" marL="0">
-              <a:buNone/>
-            </a:pPr>
-            <a:r>
-              <a:rPr lang="en-US" sz="1650" b="1" spc="169" kern="0" dirty="0">
-                <a:solidFill>
-                  <a:srgbClr val="CFE8E2"/>
-                </a:solidFill>
-                <a:latin typeface="Be Vietnam Pro" pitchFamily="34" charset="0"/>
-                <a:ea typeface="Be Vietnam Pro" pitchFamily="34" charset="-122"/>
-                <a:cs typeface="Be Vietnam Pro" pitchFamily="34" charset="-120"/>
-              </a:rPr>
-              <a:t>MÁY</a:t>
-            </a:r>
-            <a:r>
-              <a:rPr lang="en-US" sz="1650" b="1" spc="226" kern="0" dirty="0">
-                <a:solidFill>
-                  <a:srgbClr val="CFE8E2"/>
-                </a:solidFill>
-                <a:latin typeface="Be Vietnam Pro" pitchFamily="34" charset="0"/>
-                <a:ea typeface="Be Vietnam Pro" pitchFamily="34" charset="-122"/>
-                <a:cs typeface="Be Vietnam Pro" pitchFamily="34" charset="-120"/>
-              </a:rPr>
-              <a:t> CHỦ VPN</a:t>
-            </a:r>
-            <a:endParaRPr lang="en-US" sz="1650" dirty="0"/>
-          </a:p>
-        </p:txBody>
-      </p:sp>
-      <p:sp>
-        <p:nvSpPr>
-          <p:cNvPr id="24" name="Text 22"/>
-          <p:cNvSpPr/>
-          <p:nvPr/>
-        </p:nvSpPr>
-        <p:spPr>
-          <a:xfrm>
-            <a:off x="9525000" y="4476750"/>
-            <a:ext cx="7524750" cy="914400"/>
+            <a:off x="9525000" y="3295650"/>
+            <a:ext cx="7524750" cy="876300"/>
           </a:xfrm>
           <a:prstGeom prst="rect">
             <a:avLst/>
@@ -26150,7 +26301,7 @@
               <a:t>Thấy</a:t>
             </a:r>
             <a:r>
-              <a:rPr lang="en-US" sz="2550" b="1" dirty="0" spc="15" kern="0">
+              <a:rPr lang="en-US" sz="2550" b="1" dirty="0" spc="0" kern="0">
                 <a:solidFill>
                   <a:srgbClr val="FFFFFF"/>
                 </a:solidFill>
@@ -26158,7 +26309,40 @@
                 <a:ea typeface="Be Vietnam Pro" pitchFamily="34" charset="-122"/>
                 <a:cs typeface="Be Vietnam Pro" pitchFamily="34" charset="-120"/>
               </a:rPr>
-              <a:t> địa</a:t>
+              <a:t> bạn</a:t>
+            </a:r>
+            <a:r>
+              <a:rPr lang="en-US" sz="2550" b="1" dirty="0" spc="-3" kern="0">
+                <a:solidFill>
+                  <a:srgbClr val="FFFFFF"/>
+                </a:solidFill>
+                <a:latin typeface="Be Vietnam Pro" pitchFamily="34" charset="0"/>
+                <a:ea typeface="Be Vietnam Pro" pitchFamily="34" charset="-122"/>
+                <a:cs typeface="Be Vietnam Pro" pitchFamily="34" charset="-120"/>
+              </a:rPr>
+              <a:t> nối</a:t>
+            </a:r>
+            <a:r>
+              <a:rPr lang="en-US" sz="2550" b="1" dirty="0" spc="4" kern="0">
+                <a:solidFill>
+                  <a:srgbClr val="FFFFFF"/>
+                </a:solidFill>
+                <a:latin typeface="Be Vietnam Pro" pitchFamily="34" charset="0"/>
+                <a:ea typeface="Be Vietnam Pro" pitchFamily="34" charset="-122"/>
+                <a:cs typeface="Be Vietnam Pro" pitchFamily="34" charset="-120"/>
+              </a:rPr>
+              <a:t> tới</a:t>
+            </a:r>
+            <a:r>
+              <a:rPr lang="en-US" sz="2550" b="1" dirty="0" spc="-3" kern="0">
+                <a:solidFill>
+                  <a:srgbClr val="FFFFFF"/>
+                </a:solidFill>
+                <a:latin typeface="Be Vietnam Pro" pitchFamily="34" charset="0"/>
+                <a:ea typeface="Be Vietnam Pro" pitchFamily="34" charset="-122"/>
+                <a:cs typeface="Be Vietnam Pro" pitchFamily="34" charset="-120"/>
+              </a:rPr>
+              <a:t> VPN,</a:t>
             </a:r>
             <a:r>
               <a:rPr lang="en-US" sz="2550" b="1" dirty="0" spc="0" kern="0">
@@ -26169,10 +26353,10 @@
                 <a:ea typeface="Be Vietnam Pro" pitchFamily="34" charset="-122"/>
                 <a:cs typeface="Be Vietnam Pro" pitchFamily="34" charset="-120"/>
               </a:rPr>
-              <a:t> chỉ</a:t>
-            </a:r>
-            <a:r>
-              <a:rPr lang="en-US" sz="2550" b="1" dirty="0" spc="-5" kern="0">
+              <a:t> kích</a:t>
+            </a:r>
+            <a:r>
+              <a:rPr lang="en-US" sz="2550" b="1" dirty="0" spc="8" kern="0">
                 <a:solidFill>
                   <a:srgbClr val="FFFFFF"/>
                 </a:solidFill>
@@ -26180,7 +26364,18 @@
                 <a:ea typeface="Be Vietnam Pro" pitchFamily="34" charset="-122"/>
                 <a:cs typeface="Be Vietnam Pro" pitchFamily="34" charset="-120"/>
               </a:rPr>
-              <a:t> thật,</a:t>
+              <a:t> thước,</a:t>
+            </a:r>
+            <a:r>
+              <a:rPr lang="en-US" sz="2550" b="1" dirty="0" spc="4" kern="0">
+                <a:solidFill>
+                  <a:srgbClr val="FFFFFF"/>
+                </a:solidFill>
+                <a:latin typeface="Be Vietnam Pro" pitchFamily="34" charset="0"/>
+                <a:ea typeface="Be Vietnam Pro" pitchFamily="34" charset="-122"/>
+                <a:cs typeface="Be Vietnam Pro" pitchFamily="34" charset="-120"/>
+              </a:rPr>
+              <a:t> thời</a:t>
             </a:r>
             <a:r>
               <a:rPr lang="en-US" sz="2550" b="1" dirty="0" spc="10" kern="0">
@@ -26191,62 +26386,7 @@
                 <a:ea typeface="Be Vietnam Pro" pitchFamily="34" charset="-122"/>
                 <a:cs typeface="Be Vietnam Pro" pitchFamily="34" charset="-120"/>
               </a:rPr>
-              <a:t> đích,</a:t>
-            </a:r>
-            <a:r>
-              <a:rPr lang="en-US" sz="2550" b="1" dirty="0" spc="-4" kern="0">
-                <a:solidFill>
-                  <a:srgbClr val="FFFFFF"/>
-                </a:solidFill>
-                <a:latin typeface="Be Vietnam Pro" pitchFamily="34" charset="0"/>
-                <a:ea typeface="Be Vietnam Pro" pitchFamily="34" charset="-122"/>
-                <a:cs typeface="Be Vietnam Pro" pitchFamily="34" charset="-120"/>
-              </a:rPr>
-              <a:t> cả</a:t>
-            </a:r>
-            <a:r>
-              <a:rPr lang="en-US" sz="2550" b="1" dirty="0" spc="-5" kern="0">
-                <a:solidFill>
-                  <a:srgbClr val="FFFFFF"/>
-                </a:solidFill>
-                <a:latin typeface="Be Vietnam Pro" pitchFamily="34" charset="0"/>
-                <a:ea typeface="Be Vietnam Pro" pitchFamily="34" charset="-122"/>
-                <a:cs typeface="Be Vietnam Pro" pitchFamily="34" charset="-120"/>
-              </a:rPr>
-              <a:t> thông</a:t>
-            </a:r>
-            <a:r>
-              <a:rPr lang="en-US" sz="2550" b="1" dirty="0" spc="1" kern="0">
-                <a:solidFill>
-                  <a:srgbClr val="FFFFFF"/>
-                </a:solidFill>
-                <a:latin typeface="Be Vietnam Pro" pitchFamily="34" charset="0"/>
-                <a:ea typeface="Be Vietnam Pro" pitchFamily="34" charset="-122"/>
-                <a:cs typeface="Be Vietnam Pro" pitchFamily="34" charset="-120"/>
-              </a:rPr>
-              <a:t> tin</a:t>
-            </a:r>
-            <a:r>
-              <a:rPr lang="en-US" sz="2550" b="1" dirty="0" spc="3" kern="0">
-                <a:solidFill>
-                  <a:srgbClr val="FFFFFF"/>
-                </a:solidFill>
-                <a:latin typeface="Be Vietnam Pro" pitchFamily="34" charset="0"/>
-                <a:ea typeface="Be Vietnam Pro" pitchFamily="34" charset="-122"/>
-                <a:cs typeface="Be Vietnam Pro" pitchFamily="34" charset="-120"/>
-              </a:rPr>
-              <a:t> đăng</a:t>
-            </a:r>
-            <a:r>
-              <a:rPr lang="en-US" sz="2550" b="1" dirty="0" spc="0" kern="0">
-                <a:solidFill>
-                  <a:srgbClr val="FFFFFF"/>
-                </a:solidFill>
-                <a:latin typeface="Be Vietnam Pro" pitchFamily="34" charset="0"/>
-                <a:ea typeface="Be Vietnam Pro" pitchFamily="34" charset="-122"/>
-                <a:cs typeface="Be Vietnam Pro" pitchFamily="34" charset="-120"/>
-              </a:rPr>
-              <a:t> nhập</a:t>
+              <a:t> điểm</a:t>
             </a:r>
             <a:endParaRPr lang="en-US" sz="2550" dirty="0"/>
           </a:p>
@@ -26254,13 +26394,13 @@
       </p:sp>
       <p:sp>
         <p:nvSpPr>
-          <p:cNvPr id="25" name="Text 23"/>
-          <p:cNvSpPr/>
-          <p:nvPr/>
-        </p:nvSpPr>
-        <p:spPr>
-          <a:xfrm>
-            <a:off x="9525000" y="5619750"/>
+          <p:cNvPr id="23" name="Text 21"/>
+          <p:cNvSpPr/>
+          <p:nvPr/>
+        </p:nvSpPr>
+        <p:spPr>
+          <a:xfrm>
+            <a:off x="9525000" y="4305300"/>
             <a:ext cx="7429500" cy="266700"/>
           </a:xfrm>
           <a:prstGeom prst="rect">
@@ -26277,15 +26417,26 @@
               <a:buNone/>
             </a:pPr>
             <a:r>
-              <a:rPr lang="en-US" sz="1650" b="1" spc="223" kern="0" dirty="0">
-                <a:solidFill>
-                  <a:srgbClr val="F3EEE3"/>
-                </a:solidFill>
-                <a:latin typeface="Be Vietnam Pro" pitchFamily="34" charset="0"/>
-                <a:ea typeface="Be Vietnam Pro" pitchFamily="34" charset="-122"/>
-                <a:cs typeface="Be Vietnam Pro" pitchFamily="34" charset="-120"/>
-              </a:rPr>
-              <a:t>TRANG WEB</a:t>
+              <a:rPr lang="en-US" sz="1650" b="1" spc="169" kern="0" dirty="0">
+                <a:solidFill>
+                  <a:srgbClr val="CFE8E2"/>
+                </a:solidFill>
+                <a:latin typeface="Be Vietnam Pro" pitchFamily="34" charset="0"/>
+                <a:ea typeface="Be Vietnam Pro" pitchFamily="34" charset="-122"/>
+                <a:cs typeface="Be Vietnam Pro" pitchFamily="34" charset="-120"/>
+              </a:rPr>
+              <a:t>MÁY</a:t>
+            </a:r>
+            <a:r>
+              <a:rPr lang="en-US" sz="1650" b="1" spc="226" kern="0" dirty="0">
+                <a:solidFill>
+                  <a:srgbClr val="CFE8E2"/>
+                </a:solidFill>
+                <a:latin typeface="Be Vietnam Pro" pitchFamily="34" charset="0"/>
+                <a:ea typeface="Be Vietnam Pro" pitchFamily="34" charset="-122"/>
+                <a:cs typeface="Be Vietnam Pro" pitchFamily="34" charset="-120"/>
+              </a:rPr>
+              <a:t> CHỦ VPN</a:t>
             </a:r>
             <a:endParaRPr lang="en-US" sz="1650" dirty="0"/>
           </a:p>
@@ -26293,14 +26444,14 @@
       </p:sp>
       <p:sp>
         <p:nvSpPr>
-          <p:cNvPr id="26" name="Text 24"/>
-          <p:cNvSpPr/>
-          <p:nvPr/>
-        </p:nvSpPr>
-        <p:spPr>
-          <a:xfrm>
-            <a:off x="9525000" y="5943600"/>
-            <a:ext cx="7524750" cy="914400"/>
+          <p:cNvPr id="24" name="Text 22"/>
+          <p:cNvSpPr/>
+          <p:nvPr/>
+        </p:nvSpPr>
+        <p:spPr>
+          <a:xfrm>
+            <a:off x="9525000" y="4629150"/>
+            <a:ext cx="7524750" cy="876300"/>
           </a:xfrm>
           <a:prstGeom prst="rect">
             <a:avLst/>
@@ -26352,7 +26503,7 @@
               <a:t> chỉ</a:t>
             </a:r>
             <a:r>
-              <a:rPr lang="en-US" sz="2550" b="1" dirty="0" spc="-12" kern="0">
+              <a:rPr lang="en-US" sz="2550" b="1" dirty="0" spc="-5" kern="0">
                 <a:solidFill>
                   <a:srgbClr val="FFFFFF"/>
                 </a:solidFill>
@@ -26360,10 +26511,10 @@
                 <a:ea typeface="Be Vietnam Pro" pitchFamily="34" charset="-122"/>
                 <a:cs typeface="Be Vietnam Pro" pitchFamily="34" charset="-120"/>
               </a:rPr>
-              <a:t> máy</a:t>
-            </a:r>
-            <a:r>
-              <a:rPr lang="en-US" sz="2550" b="1" dirty="0" spc="-1" kern="0">
+              <a:t> thật,</a:t>
+            </a:r>
+            <a:r>
+              <a:rPr lang="en-US" sz="2550" b="1" dirty="0" spc="10" kern="0">
                 <a:solidFill>
                   <a:srgbClr val="FFFFFF"/>
                 </a:solidFill>
@@ -26371,10 +26522,10 @@
                 <a:ea typeface="Be Vietnam Pro" pitchFamily="34" charset="-122"/>
                 <a:cs typeface="Be Vietnam Pro" pitchFamily="34" charset="-120"/>
               </a:rPr>
-              <a:t> chủ</a:t>
-            </a:r>
-            <a:r>
-              <a:rPr lang="en-US" sz="2550" b="1" dirty="0" spc="-3" kern="0">
+              <a:t> đích,</a:t>
+            </a:r>
+            <a:r>
+              <a:rPr lang="en-US" sz="2550" b="1" dirty="0" spc="-4" kern="0">
                 <a:solidFill>
                   <a:srgbClr val="FFFFFF"/>
                 </a:solidFill>
@@ -26382,10 +26533,10 @@
                 <a:ea typeface="Be Vietnam Pro" pitchFamily="34" charset="-122"/>
                 <a:cs typeface="Be Vietnam Pro" pitchFamily="34" charset="-120"/>
               </a:rPr>
-              <a:t> VPN,</a:t>
-            </a:r>
-            <a:r>
-              <a:rPr lang="en-US" sz="2550" b="1" dirty="0" spc="-1" kern="0">
+              <a:t> cả</a:t>
+            </a:r>
+            <a:r>
+              <a:rPr lang="en-US" sz="2550" b="1" dirty="0" spc="-5" kern="0">
                 <a:solidFill>
                   <a:srgbClr val="FFFFFF"/>
                 </a:solidFill>
@@ -26393,10 +26544,10 @@
                 <a:ea typeface="Be Vietnam Pro" pitchFamily="34" charset="-122"/>
                 <a:cs typeface="Be Vietnam Pro" pitchFamily="34" charset="-120"/>
               </a:rPr>
-              <a:t> nhận</a:t>
-            </a:r>
-            <a:r>
-              <a:rPr lang="en-US" sz="2550" b="1" dirty="0" spc="-20" kern="0">
+              <a:t> thông</a:t>
+            </a:r>
+            <a:r>
+              <a:rPr lang="en-US" sz="2550" b="1" dirty="0" spc="1" kern="0">
                 <a:solidFill>
                   <a:srgbClr val="FFFFFF"/>
                 </a:solidFill>
@@ -26404,7 +26555,18 @@
                 <a:ea typeface="Be Vietnam Pro" pitchFamily="34" charset="-122"/>
                 <a:cs typeface="Be Vietnam Pro" pitchFamily="34" charset="-120"/>
               </a:rPr>
-              <a:t> ra</a:t>
+              <a:t> tin</a:t>
+            </a:r>
+            <a:r>
+              <a:rPr lang="en-US" sz="2550" b="1" dirty="0" spc="3" kern="0">
+                <a:solidFill>
+                  <a:srgbClr val="FFFFFF"/>
+                </a:solidFill>
+                <a:latin typeface="Be Vietnam Pro" pitchFamily="34" charset="0"/>
+                <a:ea typeface="Be Vietnam Pro" pitchFamily="34" charset="-122"/>
+                <a:cs typeface="Be Vietnam Pro" pitchFamily="34" charset="-120"/>
+              </a:rPr>
+              <a:t> đăng</a:t>
             </a:r>
             <a:r>
               <a:rPr lang="en-US" sz="2550" b="1" dirty="0" spc="0" kern="0">
@@ -26415,18 +26577,7 @@
                 <a:ea typeface="Be Vietnam Pro" pitchFamily="34" charset="-122"/>
                 <a:cs typeface="Be Vietnam Pro" pitchFamily="34" charset="-120"/>
               </a:rPr>
-              <a:t> tài</a:t>
-            </a:r>
-            <a:r>
-              <a:rPr lang="en-US" sz="2550" b="1" dirty="0" spc="-2" kern="0">
-                <a:solidFill>
-                  <a:srgbClr val="FFFFFF"/>
-                </a:solidFill>
-                <a:latin typeface="Be Vietnam Pro" pitchFamily="34" charset="0"/>
-                <a:ea typeface="Be Vietnam Pro" pitchFamily="34" charset="-122"/>
-                <a:cs typeface="Be Vietnam Pro" pitchFamily="34" charset="-120"/>
-              </a:rPr>
-              <a:t> khoản</a:t>
+              <a:t> nhập</a:t>
             </a:r>
             <a:endParaRPr lang="en-US" sz="2550" dirty="0"/>
           </a:p>
@@ -26434,7 +26585,187 @@
       </p:sp>
       <p:sp>
         <p:nvSpPr>
-          <p:cNvPr id="27" name="Connector line-1792383535585-276129507"/>
+          <p:cNvPr id="25" name="Text 23"/>
+          <p:cNvSpPr/>
+          <p:nvPr/>
+        </p:nvSpPr>
+        <p:spPr>
+          <a:xfrm>
+            <a:off x="9525000" y="5676900"/>
+            <a:ext cx="7429500" cy="266700"/>
+          </a:xfrm>
+          <a:prstGeom prst="rect">
+            <a:avLst/>
+          </a:prstGeom>
+          <a:noFill/>
+          <a:ln/>
+        </p:spPr>
+        <p:txBody>
+          <a:bodyPr wrap="square" lIns="0" tIns="0" rIns="0" bIns="0" rtlCol="0" anchor="t"/>
+          <a:lstStyle/>
+          <a:p>
+            <a:pPr algn="l" indent="0" marL="0">
+              <a:buNone/>
+            </a:pPr>
+            <a:r>
+              <a:rPr lang="en-US" sz="1650" b="1" spc="223" kern="0" dirty="0">
+                <a:solidFill>
+                  <a:srgbClr val="F3EEE3"/>
+                </a:solidFill>
+                <a:latin typeface="Be Vietnam Pro" pitchFamily="34" charset="0"/>
+                <a:ea typeface="Be Vietnam Pro" pitchFamily="34" charset="-122"/>
+                <a:cs typeface="Be Vietnam Pro" pitchFamily="34" charset="-120"/>
+              </a:rPr>
+              <a:t>TRANG WEB</a:t>
+            </a:r>
+            <a:endParaRPr lang="en-US" sz="1650" dirty="0"/>
+          </a:p>
+        </p:txBody>
+      </p:sp>
+      <p:sp>
+        <p:nvSpPr>
+          <p:cNvPr id="26" name="Text 24"/>
+          <p:cNvSpPr/>
+          <p:nvPr/>
+        </p:nvSpPr>
+        <p:spPr>
+          <a:xfrm>
+            <a:off x="9525000" y="6000750"/>
+            <a:ext cx="7524750" cy="876300"/>
+          </a:xfrm>
+          <a:prstGeom prst="rect">
+            <a:avLst/>
+          </a:prstGeom>
+          <a:noFill/>
+          <a:ln/>
+        </p:spPr>
+        <p:txBody>
+          <a:bodyPr wrap="square" lIns="0" tIns="17796" rIns="0" bIns="-17796" rtlCol="0" anchor="t"/>
+          <a:lstStyle/>
+          <a:p>
+            <a:pPr algn="l" indent="0" marL="0">
+              <a:lnSpc>
+                <a:spcPts val="3188"/>
+              </a:lnSpc>
+              <a:buNone/>
+            </a:pPr>
+            <a:r>
+              <a:rPr lang="en-US" sz="2550" b="1" dirty="0" spc="-11" kern="0">
+                <a:solidFill>
+                  <a:srgbClr val="FFFFFF"/>
+                </a:solidFill>
+                <a:latin typeface="Be Vietnam Pro" pitchFamily="34" charset="0"/>
+                <a:ea typeface="Be Vietnam Pro" pitchFamily="34" charset="-122"/>
+                <a:cs typeface="Be Vietnam Pro" pitchFamily="34" charset="-120"/>
+              </a:rPr>
+              <a:t>Thấy</a:t>
+            </a:r>
+            <a:r>
+              <a:rPr lang="en-US" sz="2550" b="1" dirty="0" spc="15" kern="0">
+                <a:solidFill>
+                  <a:srgbClr val="FFFFFF"/>
+                </a:solidFill>
+                <a:latin typeface="Be Vietnam Pro" pitchFamily="34" charset="0"/>
+                <a:ea typeface="Be Vietnam Pro" pitchFamily="34" charset="-122"/>
+                <a:cs typeface="Be Vietnam Pro" pitchFamily="34" charset="-120"/>
+              </a:rPr>
+              <a:t> địa</a:t>
+            </a:r>
+            <a:r>
+              <a:rPr lang="en-US" sz="2550" b="1" dirty="0" spc="0" kern="0">
+                <a:solidFill>
+                  <a:srgbClr val="FFFFFF"/>
+                </a:solidFill>
+                <a:latin typeface="Be Vietnam Pro" pitchFamily="34" charset="0"/>
+                <a:ea typeface="Be Vietnam Pro" pitchFamily="34" charset="-122"/>
+                <a:cs typeface="Be Vietnam Pro" pitchFamily="34" charset="-120"/>
+              </a:rPr>
+              <a:t> chỉ</a:t>
+            </a:r>
+            <a:r>
+              <a:rPr lang="en-US" sz="2550" b="1" dirty="0" spc="-12" kern="0">
+                <a:solidFill>
+                  <a:srgbClr val="FFFFFF"/>
+                </a:solidFill>
+                <a:latin typeface="Be Vietnam Pro" pitchFamily="34" charset="0"/>
+                <a:ea typeface="Be Vietnam Pro" pitchFamily="34" charset="-122"/>
+                <a:cs typeface="Be Vietnam Pro" pitchFamily="34" charset="-120"/>
+              </a:rPr>
+              <a:t> máy</a:t>
+            </a:r>
+            <a:r>
+              <a:rPr lang="en-US" sz="2550" b="1" dirty="0" spc="-1" kern="0">
+                <a:solidFill>
+                  <a:srgbClr val="FFFFFF"/>
+                </a:solidFill>
+                <a:latin typeface="Be Vietnam Pro" pitchFamily="34" charset="0"/>
+                <a:ea typeface="Be Vietnam Pro" pitchFamily="34" charset="-122"/>
+                <a:cs typeface="Be Vietnam Pro" pitchFamily="34" charset="-120"/>
+              </a:rPr>
+              <a:t> chủ</a:t>
+            </a:r>
+            <a:r>
+              <a:rPr lang="en-US" sz="2550" b="1" dirty="0" spc="-3" kern="0">
+                <a:solidFill>
+                  <a:srgbClr val="FFFFFF"/>
+                </a:solidFill>
+                <a:latin typeface="Be Vietnam Pro" pitchFamily="34" charset="0"/>
+                <a:ea typeface="Be Vietnam Pro" pitchFamily="34" charset="-122"/>
+                <a:cs typeface="Be Vietnam Pro" pitchFamily="34" charset="-120"/>
+              </a:rPr>
+              <a:t> VPN,</a:t>
+            </a:r>
+            <a:r>
+              <a:rPr lang="en-US" sz="2550" b="1" dirty="0" spc="-1" kern="0">
+                <a:solidFill>
+                  <a:srgbClr val="FFFFFF"/>
+                </a:solidFill>
+                <a:latin typeface="Be Vietnam Pro" pitchFamily="34" charset="0"/>
+                <a:ea typeface="Be Vietnam Pro" pitchFamily="34" charset="-122"/>
+                <a:cs typeface="Be Vietnam Pro" pitchFamily="34" charset="-120"/>
+              </a:rPr>
+              <a:t> nhận</a:t>
+            </a:r>
+            <a:r>
+              <a:rPr lang="en-US" sz="2550" b="1" dirty="0" spc="-20" kern="0">
+                <a:solidFill>
+                  <a:srgbClr val="FFFFFF"/>
+                </a:solidFill>
+                <a:latin typeface="Be Vietnam Pro" pitchFamily="34" charset="0"/>
+                <a:ea typeface="Be Vietnam Pro" pitchFamily="34" charset="-122"/>
+                <a:cs typeface="Be Vietnam Pro" pitchFamily="34" charset="-120"/>
+              </a:rPr>
+              <a:t> ra</a:t>
+            </a:r>
+            <a:r>
+              <a:rPr lang="en-US" sz="2550" b="1" dirty="0" spc="0" kern="0">
+                <a:solidFill>
+                  <a:srgbClr val="FFFFFF"/>
+                </a:solidFill>
+                <a:latin typeface="Be Vietnam Pro" pitchFamily="34" charset="0"/>
+                <a:ea typeface="Be Vietnam Pro" pitchFamily="34" charset="-122"/>
+                <a:cs typeface="Be Vietnam Pro" pitchFamily="34" charset="-120"/>
+              </a:rPr>
+              <a:t> tài</a:t>
+            </a:r>
+            <a:r>
+              <a:rPr lang="en-US" sz="2550" b="1" dirty="0" spc="-2" kern="0">
+                <a:solidFill>
+                  <a:srgbClr val="FFFFFF"/>
+                </a:solidFill>
+                <a:latin typeface="Be Vietnam Pro" pitchFamily="34" charset="0"/>
+                <a:ea typeface="Be Vietnam Pro" pitchFamily="34" charset="-122"/>
+                <a:cs typeface="Be Vietnam Pro" pitchFamily="34" charset="-120"/>
+              </a:rPr>
+              <a:t> khoản</a:t>
+            </a:r>
+            <a:endParaRPr lang="en-US" sz="2550" dirty="0"/>
+          </a:p>
+        </p:txBody>
+      </p:sp>
+      <p:sp>
+        <p:nvSpPr>
+          <p:cNvPr id="27" name="Connector line-1792405109632-397535402"/>
           <p:cNvSpPr/>
           <p:nvPr/>
         </p:nvSpPr>
@@ -26817,7 +27148,7 @@
       </p:sp>
       <p:sp>
         <p:nvSpPr>
-          <p:cNvPr id="30" name="Connector line-1792383535588-287548533"/>
+          <p:cNvPr id="30" name="Connector line-1792405109635-717824945"/>
           <p:cNvSpPr/>
           <p:nvPr/>
         </p:nvSpPr>

</xml_diff>